<commit_message>
docs: add temperature=0 vs default slide to MAKING_OF.pptx (now 11 slides)
Insert slide 8 explaining when the site pins temperature=0 (categorization/
scoring tasks that are saved, shared, cached) vs leaves the API default
(translation, mind maps, auto-categories), with a same-file re-upload example.

Co-Authored-By: Claude Opus 4.8 <noreply@anthropic.com>
Claude-Session: https://claude.ai/code/session_01FpuqpHkDSzyM6ovhp8kzVo
</commit_message>
<xml_diff>
--- a/MAKING_OF.pptx
+++ b/MAKING_OF.pptx
@@ -15,6 +15,7 @@
     <p:sldId id="263" r:id="rId14"/>
     <p:sldId id="264" r:id="rId15"/>
     <p:sldId id="265" r:id="rId16"/>
+    <p:sldId id="266" r:id="rId17"/>
   </p:sldIdLst>
   <p:sldSz cx="12191695" cy="6858000" type="screen4x3"/>
   <p:notesSz cx="6858000" cy="9144000"/>
@@ -3376,6 +3377,1122 @@
 </file>
 
 <file path=ppt/slides/slide10.xml><?xml version="1.0" encoding="utf-8"?>
+<p:sld xmlns:a="http://schemas.openxmlformats.org/drawingml/2006/main" xmlns:p="http://schemas.openxmlformats.org/presentationml/2006/main" xmlns:r="http://schemas.openxmlformats.org/officeDocument/2006/relationships">
+  <p:cSld>
+    <p:spTree>
+      <p:nvGrpSpPr>
+        <p:cNvPr id="1" name=""/>
+        <p:cNvGrpSpPr/>
+        <p:nvPr/>
+      </p:nvGrpSpPr>
+      <p:grpSpPr/>
+      <p:sp>
+        <p:nvSpPr>
+          <p:cNvPr id="2" name="Rectangle 1"/>
+          <p:cNvSpPr/>
+          <p:nvPr/>
+        </p:nvSpPr>
+        <p:spPr>
+          <a:xfrm>
+            <a:off x="0" y="0"/>
+            <a:ext cx="12191695" cy="6858000"/>
+          </a:xfrm>
+          <a:prstGeom prst="rect">
+            <a:avLst/>
+          </a:prstGeom>
+          <a:solidFill>
+            <a:srgbClr val="F8FAFC"/>
+          </a:solidFill>
+          <a:ln>
+            <a:noFill/>
+          </a:ln>
+          <a:effectLst/>
+        </p:spPr>
+        <p:style>
+          <a:lnRef idx="1">
+            <a:schemeClr val="accent1"/>
+          </a:lnRef>
+          <a:fillRef idx="3">
+            <a:schemeClr val="accent1"/>
+          </a:fillRef>
+          <a:effectRef idx="2">
+            <a:schemeClr val="accent1"/>
+          </a:effectRef>
+          <a:fontRef idx="minor">
+            <a:schemeClr val="lt1"/>
+          </a:fontRef>
+        </p:style>
+        <p:txBody>
+          <a:bodyPr rtlCol="0" anchor="ctr"/>
+          <a:lstStyle/>
+          <a:p>
+            <a:pPr algn="ctr"/>
+          </a:p>
+        </p:txBody>
+      </p:sp>
+      <p:sp>
+        <p:nvSpPr>
+          <p:cNvPr id="3" name="Rectangle 2"/>
+          <p:cNvSpPr/>
+          <p:nvPr/>
+        </p:nvSpPr>
+        <p:spPr>
+          <a:xfrm>
+            <a:off x="0" y="0"/>
+            <a:ext cx="12191695" cy="1143000"/>
+          </a:xfrm>
+          <a:prstGeom prst="rect">
+            <a:avLst/>
+          </a:prstGeom>
+          <a:solidFill>
+            <a:srgbClr val="1F2937"/>
+          </a:solidFill>
+          <a:ln>
+            <a:noFill/>
+          </a:ln>
+          <a:effectLst/>
+        </p:spPr>
+        <p:style>
+          <a:lnRef idx="1">
+            <a:schemeClr val="accent1"/>
+          </a:lnRef>
+          <a:fillRef idx="3">
+            <a:schemeClr val="accent1"/>
+          </a:fillRef>
+          <a:effectRef idx="2">
+            <a:schemeClr val="accent1"/>
+          </a:effectRef>
+          <a:fontRef idx="minor">
+            <a:schemeClr val="lt1"/>
+          </a:fontRef>
+        </p:style>
+        <p:txBody>
+          <a:bodyPr rtlCol="0" anchor="ctr"/>
+          <a:lstStyle/>
+          <a:p>
+            <a:pPr algn="ctr"/>
+          </a:p>
+        </p:txBody>
+      </p:sp>
+      <p:sp>
+        <p:nvSpPr>
+          <p:cNvPr id="4" name="Rectangle 3"/>
+          <p:cNvSpPr/>
+          <p:nvPr/>
+        </p:nvSpPr>
+        <p:spPr>
+          <a:xfrm>
+            <a:off x="0" y="1143000"/>
+            <a:ext cx="12191695" cy="50800"/>
+          </a:xfrm>
+          <a:prstGeom prst="rect">
+            <a:avLst/>
+          </a:prstGeom>
+          <a:solidFill>
+            <a:srgbClr val="2563EB"/>
+          </a:solidFill>
+          <a:ln>
+            <a:noFill/>
+          </a:ln>
+          <a:effectLst/>
+        </p:spPr>
+        <p:style>
+          <a:lnRef idx="1">
+            <a:schemeClr val="accent1"/>
+          </a:lnRef>
+          <a:fillRef idx="3">
+            <a:schemeClr val="accent1"/>
+          </a:fillRef>
+          <a:effectRef idx="2">
+            <a:schemeClr val="accent1"/>
+          </a:effectRef>
+          <a:fontRef idx="minor">
+            <a:schemeClr val="lt1"/>
+          </a:fontRef>
+        </p:style>
+        <p:txBody>
+          <a:bodyPr rtlCol="0" anchor="ctr"/>
+          <a:lstStyle/>
+          <a:p>
+            <a:pPr algn="ctr"/>
+          </a:p>
+        </p:txBody>
+      </p:sp>
+      <p:sp>
+        <p:nvSpPr>
+          <p:cNvPr id="5" name="TextBox 4"/>
+          <p:cNvSpPr txBox="1"/>
+          <p:nvPr/>
+        </p:nvSpPr>
+        <p:spPr>
+          <a:xfrm>
+            <a:off x="548640" y="146304"/>
+            <a:ext cx="10972800" cy="365760"/>
+          </a:xfrm>
+          <a:prstGeom prst="rect">
+            <a:avLst/>
+          </a:prstGeom>
+          <a:noFill/>
+        </p:spPr>
+        <p:txBody>
+          <a:bodyPr wrap="square" anchor="t">
+            <a:spAutoFit/>
+          </a:bodyPr>
+          <a:lstStyle/>
+          <a:p>
+            <a:pPr algn="l">
+              <a:lnSpc>
+                <a:spcPct val="105000"/>
+              </a:lnSpc>
+              <a:spcAft>
+                <a:spcPts val="600"/>
+              </a:spcAft>
+            </a:pPr>
+            <a:r>
+              <a:rPr sz="1300" b="1">
+                <a:solidFill>
+                  <a:srgbClr val="93C5FD"/>
+                </a:solidFill>
+                <a:latin typeface="맑은 고딕"/>
+              </a:rPr>
+              <a:t>숫자로 보는 결과</a:t>
+            </a:r>
+          </a:p>
+        </p:txBody>
+      </p:sp>
+      <p:sp>
+        <p:nvSpPr>
+          <p:cNvPr id="6" name="TextBox 5"/>
+          <p:cNvSpPr txBox="1"/>
+          <p:nvPr/>
+        </p:nvSpPr>
+        <p:spPr>
+          <a:xfrm>
+            <a:off x="548640" y="420624"/>
+            <a:ext cx="10972800" cy="640080"/>
+          </a:xfrm>
+          <a:prstGeom prst="rect">
+            <a:avLst/>
+          </a:prstGeom>
+          <a:noFill/>
+        </p:spPr>
+        <p:txBody>
+          <a:bodyPr wrap="square" anchor="t">
+            <a:spAutoFit/>
+          </a:bodyPr>
+          <a:lstStyle/>
+          <a:p>
+            <a:pPr algn="l">
+              <a:lnSpc>
+                <a:spcPct val="105000"/>
+              </a:lnSpc>
+              <a:spcAft>
+                <a:spcPts val="600"/>
+              </a:spcAft>
+            </a:pPr>
+            <a:r>
+              <a:rPr sz="2600" b="1">
+                <a:solidFill>
+                  <a:srgbClr val="FFFFFF"/>
+                </a:solidFill>
+                <a:latin typeface="맑은 고딕"/>
+              </a:rPr>
+              <a:t>1인 · 3주로 풀스택 서비스</a:t>
+            </a:r>
+          </a:p>
+        </p:txBody>
+      </p:sp>
+      <p:sp>
+        <p:nvSpPr>
+          <p:cNvPr id="7" name="Rectangle 6"/>
+          <p:cNvSpPr/>
+          <p:nvPr/>
+        </p:nvSpPr>
+        <p:spPr>
+          <a:xfrm>
+            <a:off x="548640" y="1554480"/>
+            <a:ext cx="3566160" cy="1691640"/>
+          </a:xfrm>
+          <a:prstGeom prst="rect">
+            <a:avLst/>
+          </a:prstGeom>
+          <a:solidFill>
+            <a:srgbClr val="FFFFFF"/>
+          </a:solidFill>
+          <a:ln w="12700">
+            <a:solidFill>
+              <a:srgbClr val="E2E8F0"/>
+            </a:solidFill>
+          </a:ln>
+          <a:effectLst/>
+        </p:spPr>
+        <p:style>
+          <a:lnRef idx="1">
+            <a:schemeClr val="accent1"/>
+          </a:lnRef>
+          <a:fillRef idx="3">
+            <a:schemeClr val="accent1"/>
+          </a:fillRef>
+          <a:effectRef idx="2">
+            <a:schemeClr val="accent1"/>
+          </a:effectRef>
+          <a:fontRef idx="minor">
+            <a:schemeClr val="lt1"/>
+          </a:fontRef>
+        </p:style>
+        <p:txBody>
+          <a:bodyPr rtlCol="0" anchor="ctr"/>
+          <a:lstStyle/>
+          <a:p>
+            <a:pPr algn="ctr"/>
+          </a:p>
+        </p:txBody>
+      </p:sp>
+      <p:sp>
+        <p:nvSpPr>
+          <p:cNvPr id="8" name="TextBox 7"/>
+          <p:cNvSpPr txBox="1"/>
+          <p:nvPr/>
+        </p:nvSpPr>
+        <p:spPr>
+          <a:xfrm>
+            <a:off x="548640" y="1828800"/>
+            <a:ext cx="3566160" cy="822960"/>
+          </a:xfrm>
+          <a:prstGeom prst="rect">
+            <a:avLst/>
+          </a:prstGeom>
+          <a:noFill/>
+        </p:spPr>
+        <p:txBody>
+          <a:bodyPr wrap="square" anchor="t">
+            <a:spAutoFit/>
+          </a:bodyPr>
+          <a:lstStyle/>
+          <a:p>
+            <a:pPr algn="ctr">
+              <a:lnSpc>
+                <a:spcPct val="105000"/>
+              </a:lnSpc>
+              <a:spcAft>
+                <a:spcPts val="600"/>
+              </a:spcAft>
+            </a:pPr>
+            <a:r>
+              <a:rPr sz="4000" b="1">
+                <a:solidFill>
+                  <a:srgbClr val="2563EB"/>
+                </a:solidFill>
+                <a:latin typeface="맑은 고딕"/>
+              </a:rPr>
+              <a:t>3주</a:t>
+            </a:r>
+          </a:p>
+        </p:txBody>
+      </p:sp>
+      <p:sp>
+        <p:nvSpPr>
+          <p:cNvPr id="9" name="TextBox 8"/>
+          <p:cNvSpPr txBox="1"/>
+          <p:nvPr/>
+        </p:nvSpPr>
+        <p:spPr>
+          <a:xfrm>
+            <a:off x="548640" y="2651760"/>
+            <a:ext cx="3566160" cy="457200"/>
+          </a:xfrm>
+          <a:prstGeom prst="rect">
+            <a:avLst/>
+          </a:prstGeom>
+          <a:noFill/>
+        </p:spPr>
+        <p:txBody>
+          <a:bodyPr wrap="square" anchor="t">
+            <a:spAutoFit/>
+          </a:bodyPr>
+          <a:lstStyle/>
+          <a:p>
+            <a:pPr algn="ctr">
+              <a:lnSpc>
+                <a:spcPct val="105000"/>
+              </a:lnSpc>
+              <a:spcAft>
+                <a:spcPts val="600"/>
+              </a:spcAft>
+            </a:pPr>
+            <a:r>
+              <a:rPr sz="1400" b="0">
+                <a:solidFill>
+                  <a:srgbClr val="374151"/>
+                </a:solidFill>
+                <a:latin typeface="맑은 고딕"/>
+              </a:rPr>
+              <a:t>개발 기간 (실작업 9일)</a:t>
+            </a:r>
+          </a:p>
+        </p:txBody>
+      </p:sp>
+      <p:sp>
+        <p:nvSpPr>
+          <p:cNvPr id="10" name="Rectangle 9"/>
+          <p:cNvSpPr/>
+          <p:nvPr/>
+        </p:nvSpPr>
+        <p:spPr>
+          <a:xfrm>
+            <a:off x="4315968" y="1554480"/>
+            <a:ext cx="3566160" cy="1691640"/>
+          </a:xfrm>
+          <a:prstGeom prst="rect">
+            <a:avLst/>
+          </a:prstGeom>
+          <a:solidFill>
+            <a:srgbClr val="FFFFFF"/>
+          </a:solidFill>
+          <a:ln w="12700">
+            <a:solidFill>
+              <a:srgbClr val="E2E8F0"/>
+            </a:solidFill>
+          </a:ln>
+          <a:effectLst/>
+        </p:spPr>
+        <p:style>
+          <a:lnRef idx="1">
+            <a:schemeClr val="accent1"/>
+          </a:lnRef>
+          <a:fillRef idx="3">
+            <a:schemeClr val="accent1"/>
+          </a:fillRef>
+          <a:effectRef idx="2">
+            <a:schemeClr val="accent1"/>
+          </a:effectRef>
+          <a:fontRef idx="minor">
+            <a:schemeClr val="lt1"/>
+          </a:fontRef>
+        </p:style>
+        <p:txBody>
+          <a:bodyPr rtlCol="0" anchor="ctr"/>
+          <a:lstStyle/>
+          <a:p>
+            <a:pPr algn="ctr"/>
+          </a:p>
+        </p:txBody>
+      </p:sp>
+      <p:sp>
+        <p:nvSpPr>
+          <p:cNvPr id="11" name="TextBox 10"/>
+          <p:cNvSpPr txBox="1"/>
+          <p:nvPr/>
+        </p:nvSpPr>
+        <p:spPr>
+          <a:xfrm>
+            <a:off x="4315968" y="1828800"/>
+            <a:ext cx="3566160" cy="822960"/>
+          </a:xfrm>
+          <a:prstGeom prst="rect">
+            <a:avLst/>
+          </a:prstGeom>
+          <a:noFill/>
+        </p:spPr>
+        <p:txBody>
+          <a:bodyPr wrap="square" anchor="t">
+            <a:spAutoFit/>
+          </a:bodyPr>
+          <a:lstStyle/>
+          <a:p>
+            <a:pPr algn="ctr">
+              <a:lnSpc>
+                <a:spcPct val="105000"/>
+              </a:lnSpc>
+              <a:spcAft>
+                <a:spcPts val="600"/>
+              </a:spcAft>
+            </a:pPr>
+            <a:r>
+              <a:rPr sz="4000" b="1">
+                <a:solidFill>
+                  <a:srgbClr val="2563EB"/>
+                </a:solidFill>
+                <a:latin typeface="맑은 고딕"/>
+              </a:rPr>
+              <a:t>50회</a:t>
+            </a:r>
+          </a:p>
+        </p:txBody>
+      </p:sp>
+      <p:sp>
+        <p:nvSpPr>
+          <p:cNvPr id="12" name="TextBox 11"/>
+          <p:cNvSpPr txBox="1"/>
+          <p:nvPr/>
+        </p:nvSpPr>
+        <p:spPr>
+          <a:xfrm>
+            <a:off x="4315968" y="2651760"/>
+            <a:ext cx="3566160" cy="457200"/>
+          </a:xfrm>
+          <a:prstGeom prst="rect">
+            <a:avLst/>
+          </a:prstGeom>
+          <a:noFill/>
+        </p:spPr>
+        <p:txBody>
+          <a:bodyPr wrap="square" anchor="t">
+            <a:spAutoFit/>
+          </a:bodyPr>
+          <a:lstStyle/>
+          <a:p>
+            <a:pPr algn="ctr">
+              <a:lnSpc>
+                <a:spcPct val="105000"/>
+              </a:lnSpc>
+              <a:spcAft>
+                <a:spcPts val="600"/>
+              </a:spcAft>
+            </a:pPr>
+            <a:r>
+              <a:rPr sz="1400" b="0">
+                <a:solidFill>
+                  <a:srgbClr val="374151"/>
+                </a:solidFill>
+                <a:latin typeface="맑은 고딕"/>
+              </a:rPr>
+              <a:t>개선 횟수(커밋)</a:t>
+            </a:r>
+          </a:p>
+        </p:txBody>
+      </p:sp>
+      <p:sp>
+        <p:nvSpPr>
+          <p:cNvPr id="13" name="Rectangle 12"/>
+          <p:cNvSpPr/>
+          <p:nvPr/>
+        </p:nvSpPr>
+        <p:spPr>
+          <a:xfrm>
+            <a:off x="8083296" y="1554480"/>
+            <a:ext cx="3566160" cy="1691640"/>
+          </a:xfrm>
+          <a:prstGeom prst="rect">
+            <a:avLst/>
+          </a:prstGeom>
+          <a:solidFill>
+            <a:srgbClr val="FFFFFF"/>
+          </a:solidFill>
+          <a:ln w="12700">
+            <a:solidFill>
+              <a:srgbClr val="E2E8F0"/>
+            </a:solidFill>
+          </a:ln>
+          <a:effectLst/>
+        </p:spPr>
+        <p:style>
+          <a:lnRef idx="1">
+            <a:schemeClr val="accent1"/>
+          </a:lnRef>
+          <a:fillRef idx="3">
+            <a:schemeClr val="accent1"/>
+          </a:fillRef>
+          <a:effectRef idx="2">
+            <a:schemeClr val="accent1"/>
+          </a:effectRef>
+          <a:fontRef idx="minor">
+            <a:schemeClr val="lt1"/>
+          </a:fontRef>
+        </p:style>
+        <p:txBody>
+          <a:bodyPr rtlCol="0" anchor="ctr"/>
+          <a:lstStyle/>
+          <a:p>
+            <a:pPr algn="ctr"/>
+          </a:p>
+        </p:txBody>
+      </p:sp>
+      <p:sp>
+        <p:nvSpPr>
+          <p:cNvPr id="14" name="TextBox 13"/>
+          <p:cNvSpPr txBox="1"/>
+          <p:nvPr/>
+        </p:nvSpPr>
+        <p:spPr>
+          <a:xfrm>
+            <a:off x="8083296" y="1828800"/>
+            <a:ext cx="3566160" cy="822960"/>
+          </a:xfrm>
+          <a:prstGeom prst="rect">
+            <a:avLst/>
+          </a:prstGeom>
+          <a:noFill/>
+        </p:spPr>
+        <p:txBody>
+          <a:bodyPr wrap="square" anchor="t">
+            <a:spAutoFit/>
+          </a:bodyPr>
+          <a:lstStyle/>
+          <a:p>
+            <a:pPr algn="ctr">
+              <a:lnSpc>
+                <a:spcPct val="105000"/>
+              </a:lnSpc>
+              <a:spcAft>
+                <a:spcPts val="600"/>
+              </a:spcAft>
+            </a:pPr>
+            <a:r>
+              <a:rPr sz="4000" b="1">
+                <a:solidFill>
+                  <a:srgbClr val="2563EB"/>
+                </a:solidFill>
+                <a:latin typeface="맑은 고딕"/>
+              </a:rPr>
+              <a:t>2.3만 줄</a:t>
+            </a:r>
+          </a:p>
+        </p:txBody>
+      </p:sp>
+      <p:sp>
+        <p:nvSpPr>
+          <p:cNvPr id="15" name="TextBox 14"/>
+          <p:cNvSpPr txBox="1"/>
+          <p:nvPr/>
+        </p:nvSpPr>
+        <p:spPr>
+          <a:xfrm>
+            <a:off x="8083296" y="2651760"/>
+            <a:ext cx="3566160" cy="457200"/>
+          </a:xfrm>
+          <a:prstGeom prst="rect">
+            <a:avLst/>
+          </a:prstGeom>
+          <a:noFill/>
+        </p:spPr>
+        <p:txBody>
+          <a:bodyPr wrap="square" anchor="t">
+            <a:spAutoFit/>
+          </a:bodyPr>
+          <a:lstStyle/>
+          <a:p>
+            <a:pPr algn="ctr">
+              <a:lnSpc>
+                <a:spcPct val="105000"/>
+              </a:lnSpc>
+              <a:spcAft>
+                <a:spcPts val="600"/>
+              </a:spcAft>
+            </a:pPr>
+            <a:r>
+              <a:rPr sz="1400" b="0">
+                <a:solidFill>
+                  <a:srgbClr val="374151"/>
+                </a:solidFill>
+                <a:latin typeface="맑은 고딕"/>
+              </a:rPr>
+              <a:t>코드 규모</a:t>
+            </a:r>
+          </a:p>
+        </p:txBody>
+      </p:sp>
+      <p:sp>
+        <p:nvSpPr>
+          <p:cNvPr id="16" name="Rectangle 15"/>
+          <p:cNvSpPr/>
+          <p:nvPr/>
+        </p:nvSpPr>
+        <p:spPr>
+          <a:xfrm>
+            <a:off x="548640" y="3520439"/>
+            <a:ext cx="3566160" cy="1691640"/>
+          </a:xfrm>
+          <a:prstGeom prst="rect">
+            <a:avLst/>
+          </a:prstGeom>
+          <a:solidFill>
+            <a:srgbClr val="FFFFFF"/>
+          </a:solidFill>
+          <a:ln w="12700">
+            <a:solidFill>
+              <a:srgbClr val="E2E8F0"/>
+            </a:solidFill>
+          </a:ln>
+          <a:effectLst/>
+        </p:spPr>
+        <p:style>
+          <a:lnRef idx="1">
+            <a:schemeClr val="accent1"/>
+          </a:lnRef>
+          <a:fillRef idx="3">
+            <a:schemeClr val="accent1"/>
+          </a:fillRef>
+          <a:effectRef idx="2">
+            <a:schemeClr val="accent1"/>
+          </a:effectRef>
+          <a:fontRef idx="minor">
+            <a:schemeClr val="lt1"/>
+          </a:fontRef>
+        </p:style>
+        <p:txBody>
+          <a:bodyPr rtlCol="0" anchor="ctr"/>
+          <a:lstStyle/>
+          <a:p>
+            <a:pPr algn="ctr"/>
+          </a:p>
+        </p:txBody>
+      </p:sp>
+      <p:sp>
+        <p:nvSpPr>
+          <p:cNvPr id="17" name="TextBox 16"/>
+          <p:cNvSpPr txBox="1"/>
+          <p:nvPr/>
+        </p:nvSpPr>
+        <p:spPr>
+          <a:xfrm>
+            <a:off x="548640" y="3794759"/>
+            <a:ext cx="3566160" cy="822960"/>
+          </a:xfrm>
+          <a:prstGeom prst="rect">
+            <a:avLst/>
+          </a:prstGeom>
+          <a:noFill/>
+        </p:spPr>
+        <p:txBody>
+          <a:bodyPr wrap="square" anchor="t">
+            <a:spAutoFit/>
+          </a:bodyPr>
+          <a:lstStyle/>
+          <a:p>
+            <a:pPr algn="ctr">
+              <a:lnSpc>
+                <a:spcPct val="105000"/>
+              </a:lnSpc>
+              <a:spcAft>
+                <a:spcPts val="600"/>
+              </a:spcAft>
+            </a:pPr>
+            <a:r>
+              <a:rPr sz="4000" b="1">
+                <a:solidFill>
+                  <a:srgbClr val="2563EB"/>
+                </a:solidFill>
+                <a:latin typeface="맑은 고딕"/>
+              </a:rPr>
+              <a:t>19종</a:t>
+            </a:r>
+          </a:p>
+        </p:txBody>
+      </p:sp>
+      <p:sp>
+        <p:nvSpPr>
+          <p:cNvPr id="18" name="TextBox 17"/>
+          <p:cNvSpPr txBox="1"/>
+          <p:nvPr/>
+        </p:nvSpPr>
+        <p:spPr>
+          <a:xfrm>
+            <a:off x="548640" y="4617719"/>
+            <a:ext cx="3566160" cy="457200"/>
+          </a:xfrm>
+          <a:prstGeom prst="rect">
+            <a:avLst/>
+          </a:prstGeom>
+          <a:noFill/>
+        </p:spPr>
+        <p:txBody>
+          <a:bodyPr wrap="square" anchor="t">
+            <a:spAutoFit/>
+          </a:bodyPr>
+          <a:lstStyle/>
+          <a:p>
+            <a:pPr algn="ctr">
+              <a:lnSpc>
+                <a:spcPct val="105000"/>
+              </a:lnSpc>
+              <a:spcAft>
+                <a:spcPts val="600"/>
+              </a:spcAft>
+            </a:pPr>
+            <a:r>
+              <a:rPr sz="1400" b="0">
+                <a:solidFill>
+                  <a:srgbClr val="374151"/>
+                </a:solidFill>
+                <a:latin typeface="맑은 고딕"/>
+              </a:rPr>
+              <a:t>자동 테스트</a:t>
+            </a:r>
+          </a:p>
+        </p:txBody>
+      </p:sp>
+      <p:sp>
+        <p:nvSpPr>
+          <p:cNvPr id="19" name="Rectangle 18"/>
+          <p:cNvSpPr/>
+          <p:nvPr/>
+        </p:nvSpPr>
+        <p:spPr>
+          <a:xfrm>
+            <a:off x="4315968" y="3520439"/>
+            <a:ext cx="3566160" cy="1691640"/>
+          </a:xfrm>
+          <a:prstGeom prst="rect">
+            <a:avLst/>
+          </a:prstGeom>
+          <a:solidFill>
+            <a:srgbClr val="FFFFFF"/>
+          </a:solidFill>
+          <a:ln w="12700">
+            <a:solidFill>
+              <a:srgbClr val="E2E8F0"/>
+            </a:solidFill>
+          </a:ln>
+          <a:effectLst/>
+        </p:spPr>
+        <p:style>
+          <a:lnRef idx="1">
+            <a:schemeClr val="accent1"/>
+          </a:lnRef>
+          <a:fillRef idx="3">
+            <a:schemeClr val="accent1"/>
+          </a:fillRef>
+          <a:effectRef idx="2">
+            <a:schemeClr val="accent1"/>
+          </a:effectRef>
+          <a:fontRef idx="minor">
+            <a:schemeClr val="lt1"/>
+          </a:fontRef>
+        </p:style>
+        <p:txBody>
+          <a:bodyPr rtlCol="0" anchor="ctr"/>
+          <a:lstStyle/>
+          <a:p>
+            <a:pPr algn="ctr"/>
+          </a:p>
+        </p:txBody>
+      </p:sp>
+      <p:sp>
+        <p:nvSpPr>
+          <p:cNvPr id="20" name="TextBox 19"/>
+          <p:cNvSpPr txBox="1"/>
+          <p:nvPr/>
+        </p:nvSpPr>
+        <p:spPr>
+          <a:xfrm>
+            <a:off x="4315968" y="3794759"/>
+            <a:ext cx="3566160" cy="822960"/>
+          </a:xfrm>
+          <a:prstGeom prst="rect">
+            <a:avLst/>
+          </a:prstGeom>
+          <a:noFill/>
+        </p:spPr>
+        <p:txBody>
+          <a:bodyPr wrap="square" anchor="t">
+            <a:spAutoFit/>
+          </a:bodyPr>
+          <a:lstStyle/>
+          <a:p>
+            <a:pPr algn="ctr">
+              <a:lnSpc>
+                <a:spcPct val="105000"/>
+              </a:lnSpc>
+              <a:spcAft>
+                <a:spcPts val="600"/>
+              </a:spcAft>
+            </a:pPr>
+            <a:r>
+              <a:rPr sz="4000" b="1">
+                <a:solidFill>
+                  <a:srgbClr val="2563EB"/>
+                </a:solidFill>
+                <a:latin typeface="맑은 고딕"/>
+              </a:rPr>
+              <a:t>4개</a:t>
+            </a:r>
+          </a:p>
+        </p:txBody>
+      </p:sp>
+      <p:sp>
+        <p:nvSpPr>
+          <p:cNvPr id="21" name="TextBox 20"/>
+          <p:cNvSpPr txBox="1"/>
+          <p:nvPr/>
+        </p:nvSpPr>
+        <p:spPr>
+          <a:xfrm>
+            <a:off x="4315968" y="4617719"/>
+            <a:ext cx="3566160" cy="457200"/>
+          </a:xfrm>
+          <a:prstGeom prst="rect">
+            <a:avLst/>
+          </a:prstGeom>
+          <a:noFill/>
+        </p:spPr>
+        <p:txBody>
+          <a:bodyPr wrap="square" anchor="t">
+            <a:spAutoFit/>
+          </a:bodyPr>
+          <a:lstStyle/>
+          <a:p>
+            <a:pPr algn="ctr">
+              <a:lnSpc>
+                <a:spcPct val="105000"/>
+              </a:lnSpc>
+              <a:spcAft>
+                <a:spcPts val="600"/>
+              </a:spcAft>
+            </a:pPr>
+            <a:r>
+              <a:rPr sz="1400" b="0">
+                <a:solidFill>
+                  <a:srgbClr val="374151"/>
+                </a:solidFill>
+                <a:latin typeface="맑은 고딕"/>
+              </a:rPr>
+              <a:t>연동 채널</a:t>
+            </a:r>
+          </a:p>
+        </p:txBody>
+      </p:sp>
+      <p:sp>
+        <p:nvSpPr>
+          <p:cNvPr id="22" name="Rectangle 21"/>
+          <p:cNvSpPr/>
+          <p:nvPr/>
+        </p:nvSpPr>
+        <p:spPr>
+          <a:xfrm>
+            <a:off x="8083296" y="3520439"/>
+            <a:ext cx="3566160" cy="1691640"/>
+          </a:xfrm>
+          <a:prstGeom prst="rect">
+            <a:avLst/>
+          </a:prstGeom>
+          <a:solidFill>
+            <a:srgbClr val="FFFFFF"/>
+          </a:solidFill>
+          <a:ln w="12700">
+            <a:solidFill>
+              <a:srgbClr val="E2E8F0"/>
+            </a:solidFill>
+          </a:ln>
+          <a:effectLst/>
+        </p:spPr>
+        <p:style>
+          <a:lnRef idx="1">
+            <a:schemeClr val="accent1"/>
+          </a:lnRef>
+          <a:fillRef idx="3">
+            <a:schemeClr val="accent1"/>
+          </a:fillRef>
+          <a:effectRef idx="2">
+            <a:schemeClr val="accent1"/>
+          </a:effectRef>
+          <a:fontRef idx="minor">
+            <a:schemeClr val="lt1"/>
+          </a:fontRef>
+        </p:style>
+        <p:txBody>
+          <a:bodyPr rtlCol="0" anchor="ctr"/>
+          <a:lstStyle/>
+          <a:p>
+            <a:pPr algn="ctr"/>
+          </a:p>
+        </p:txBody>
+      </p:sp>
+      <p:sp>
+        <p:nvSpPr>
+          <p:cNvPr id="23" name="TextBox 22"/>
+          <p:cNvSpPr txBox="1"/>
+          <p:nvPr/>
+        </p:nvSpPr>
+        <p:spPr>
+          <a:xfrm>
+            <a:off x="8083296" y="3794759"/>
+            <a:ext cx="3566160" cy="822960"/>
+          </a:xfrm>
+          <a:prstGeom prst="rect">
+            <a:avLst/>
+          </a:prstGeom>
+          <a:noFill/>
+        </p:spPr>
+        <p:txBody>
+          <a:bodyPr wrap="square" anchor="t">
+            <a:spAutoFit/>
+          </a:bodyPr>
+          <a:lstStyle/>
+          <a:p>
+            <a:pPr algn="ctr">
+              <a:lnSpc>
+                <a:spcPct val="105000"/>
+              </a:lnSpc>
+              <a:spcAft>
+                <a:spcPts val="600"/>
+              </a:spcAft>
+            </a:pPr>
+            <a:r>
+              <a:rPr sz="4000" b="1">
+                <a:solidFill>
+                  <a:srgbClr val="2563EB"/>
+                </a:solidFill>
+                <a:latin typeface="맑은 고딕"/>
+              </a:rPr>
+              <a:t>1명</a:t>
+            </a:r>
+          </a:p>
+        </p:txBody>
+      </p:sp>
+      <p:sp>
+        <p:nvSpPr>
+          <p:cNvPr id="24" name="TextBox 23"/>
+          <p:cNvSpPr txBox="1"/>
+          <p:nvPr/>
+        </p:nvSpPr>
+        <p:spPr>
+          <a:xfrm>
+            <a:off x="8083296" y="4617719"/>
+            <a:ext cx="3566160" cy="457200"/>
+          </a:xfrm>
+          <a:prstGeom prst="rect">
+            <a:avLst/>
+          </a:prstGeom>
+          <a:noFill/>
+        </p:spPr>
+        <p:txBody>
+          <a:bodyPr wrap="square" anchor="t">
+            <a:spAutoFit/>
+          </a:bodyPr>
+          <a:lstStyle/>
+          <a:p>
+            <a:pPr algn="ctr">
+              <a:lnSpc>
+                <a:spcPct val="105000"/>
+              </a:lnSpc>
+              <a:spcAft>
+                <a:spcPts val="600"/>
+              </a:spcAft>
+            </a:pPr>
+            <a:r>
+              <a:rPr sz="1400" b="0">
+                <a:solidFill>
+                  <a:srgbClr val="374151"/>
+                </a:solidFill>
+                <a:latin typeface="맑은 고딕"/>
+              </a:rPr>
+              <a:t>투입 인원</a:t>
+            </a:r>
+          </a:p>
+        </p:txBody>
+      </p:sp>
+      <p:sp>
+        <p:nvSpPr>
+          <p:cNvPr id="25" name="TextBox 24"/>
+          <p:cNvSpPr txBox="1"/>
+          <p:nvPr/>
+        </p:nvSpPr>
+        <p:spPr>
+          <a:xfrm>
+            <a:off x="548640" y="5943600"/>
+            <a:ext cx="10972800" cy="548640"/>
+          </a:xfrm>
+          <a:prstGeom prst="rect">
+            <a:avLst/>
+          </a:prstGeom>
+          <a:noFill/>
+        </p:spPr>
+        <p:txBody>
+          <a:bodyPr wrap="square" anchor="t">
+            <a:spAutoFit/>
+          </a:bodyPr>
+          <a:lstStyle/>
+          <a:p>
+            <a:pPr algn="ctr">
+              <a:lnSpc>
+                <a:spcPct val="105000"/>
+              </a:lnSpc>
+              <a:spcAft>
+                <a:spcPts val="600"/>
+              </a:spcAft>
+            </a:pPr>
+            <a:r>
+              <a:rPr sz="1500" b="0">
+                <a:solidFill>
+                  <a:srgbClr val="374151"/>
+                </a:solidFill>
+                <a:latin typeface="맑은 고딕"/>
+              </a:rPr>
+              <a:t>통상 수 명이 수개월 걸릴 풀스택 서비스를 </a:t>
+            </a:r>
+            <a:r>
+              <a:rPr sz="1500" b="1">
+                <a:solidFill>
+                  <a:srgbClr val="10B981"/>
+                </a:solidFill>
+                <a:latin typeface="맑은 고딕"/>
+              </a:rPr>
+              <a:t>1인이 3주 만에</a:t>
+            </a:r>
+            <a:r>
+              <a:rPr sz="1500" b="0">
+                <a:solidFill>
+                  <a:srgbClr val="374151"/>
+                </a:solidFill>
+                <a:latin typeface="맑은 고딕"/>
+              </a:rPr>
+              <a:t> — 이것이 생성형 AI 협업의 체감 효과입니다.</a:t>
+            </a:r>
+          </a:p>
+        </p:txBody>
+      </p:sp>
+      <p:sp>
+        <p:nvSpPr>
+          <p:cNvPr id="26" name="TextBox 25"/>
+          <p:cNvSpPr txBox="1"/>
+          <p:nvPr/>
+        </p:nvSpPr>
+        <p:spPr>
+          <a:xfrm>
+            <a:off x="11338560" y="6446520"/>
+            <a:ext cx="731520" cy="320040"/>
+          </a:xfrm>
+          <a:prstGeom prst="rect">
+            <a:avLst/>
+          </a:prstGeom>
+          <a:noFill/>
+        </p:spPr>
+        <p:txBody>
+          <a:bodyPr wrap="square" anchor="t">
+            <a:spAutoFit/>
+          </a:bodyPr>
+          <a:lstStyle/>
+          <a:p>
+            <a:pPr algn="r">
+              <a:lnSpc>
+                <a:spcPct val="105000"/>
+              </a:lnSpc>
+              <a:spcAft>
+                <a:spcPts val="600"/>
+              </a:spcAft>
+            </a:pPr>
+            <a:r>
+              <a:rPr sz="1100" b="0">
+                <a:solidFill>
+                  <a:srgbClr val="6B7280"/>
+                </a:solidFill>
+                <a:latin typeface="맑은 고딕"/>
+              </a:rPr>
+              <a:t>10</a:t>
+            </a:r>
+          </a:p>
+        </p:txBody>
+      </p:sp>
+    </p:spTree>
+  </p:cSld>
+  <p:clrMapOvr>
+    <a:masterClrMapping/>
+  </p:clrMapOvr>
+</p:sld>
+</file>
+
+<file path=ppt/slides/slide11.xml><?xml version="1.0" encoding="utf-8"?>
 <p:sld xmlns:a="http://schemas.openxmlformats.org/drawingml/2006/main" xmlns:p="http://schemas.openxmlformats.org/presentationml/2006/main" xmlns:r="http://schemas.openxmlformats.org/officeDocument/2006/relationships">
   <p:cSld>
     <p:spTree>
@@ -10411,7 +11528,7 @@
                 </a:solidFill>
                 <a:latin typeface="맑은 고딕"/>
               </a:rPr>
-              <a:t>신뢰받는 발표는 한계도 말한다</a:t>
+              <a:t>신뢰성 통제 전략</a:t>
             </a:r>
           </a:p>
         </p:txBody>
@@ -10453,21 +11570,81 @@
                 </a:solidFill>
                 <a:latin typeface="맑은 고딕"/>
               </a:rPr>
-              <a:t>AI가 "혼자" 못한 것</a:t>
-            </a:r>
-          </a:p>
-        </p:txBody>
-      </p:sp>
-      <p:sp>
-        <p:nvSpPr>
-          <p:cNvPr id="7" name="Rectangle 6"/>
+              <a:t>temperature = 0 vs 기본값 — 언제 어떻게</a:t>
+            </a:r>
+          </a:p>
+        </p:txBody>
+      </p:sp>
+      <p:sp>
+        <p:nvSpPr>
+          <p:cNvPr id="7" name="TextBox 6"/>
+          <p:cNvSpPr txBox="1"/>
+          <p:nvPr/>
+        </p:nvSpPr>
+        <p:spPr>
+          <a:xfrm>
+            <a:off x="548640" y="1298448"/>
+            <a:ext cx="11155680" cy="411480"/>
+          </a:xfrm>
+          <a:prstGeom prst="rect">
+            <a:avLst/>
+          </a:prstGeom>
+          <a:noFill/>
+        </p:spPr>
+        <p:txBody>
+          <a:bodyPr wrap="square" anchor="t">
+            <a:spAutoFit/>
+          </a:bodyPr>
+          <a:lstStyle/>
+          <a:p>
+            <a:pPr algn="l">
+              <a:lnSpc>
+                <a:spcPct val="105000"/>
+              </a:lnSpc>
+              <a:spcAft>
+                <a:spcPts val="600"/>
+              </a:spcAft>
+            </a:pPr>
+            <a:r>
+              <a:rPr sz="1400" b="0">
+                <a:solidFill>
+                  <a:srgbClr val="6B7280"/>
+                </a:solidFill>
+                <a:latin typeface="맑은 고딕"/>
+              </a:rPr>
+              <a:t>temperature = AI가 답을 고를 때 </a:t>
+            </a:r>
+            <a:r>
+              <a:rPr sz="1400" b="1">
+                <a:solidFill>
+                  <a:srgbClr val="374151"/>
+                </a:solidFill>
+                <a:latin typeface="맑은 고딕"/>
+              </a:rPr>
+              <a:t>"주사위를 던지는 정도"</a:t>
+            </a:r>
+            <a:r>
+              <a:rPr sz="1400" b="0">
+                <a:solidFill>
+                  <a:srgbClr val="6B7280"/>
+                </a:solidFill>
+                <a:latin typeface="맑은 고딕"/>
+              </a:rPr>
+              <a:t>.  0이면 주사위를 안 던져 항상 같은 답, 높을수록 표현이 매번 조금씩 달라짐.</a:t>
+            </a:r>
+          </a:p>
+        </p:txBody>
+      </p:sp>
+      <p:sp>
+        <p:nvSpPr>
+          <p:cNvPr id="8" name="Rectangle 7"/>
           <p:cNvSpPr/>
           <p:nvPr/>
         </p:nvSpPr>
         <p:spPr>
           <a:xfrm>
-            <a:off x="548640" y="1554480"/>
-            <a:ext cx="11091672" cy="1005840"/>
+            <a:off x="548640" y="1828800"/>
+            <a:ext cx="5376672" cy="2377440"/>
           </a:xfrm>
           <a:prstGeom prst="rect">
             <a:avLst/>
@@ -10506,20 +11683,20 @@
       </p:sp>
       <p:sp>
         <p:nvSpPr>
-          <p:cNvPr id="8" name="Rectangle 7"/>
+          <p:cNvPr id="9" name="Rectangle 8"/>
           <p:cNvSpPr/>
           <p:nvPr/>
         </p:nvSpPr>
         <p:spPr>
           <a:xfrm>
-            <a:off x="548640" y="1554480"/>
-            <a:ext cx="76200" cy="1005840"/>
+            <a:off x="548640" y="1828800"/>
+            <a:ext cx="5376672" cy="640080"/>
           </a:xfrm>
           <a:prstGeom prst="rect">
             <a:avLst/>
           </a:prstGeom>
           <a:solidFill>
-            <a:srgbClr val="F59E0B"/>
+            <a:srgbClr val="10B981"/>
           </a:solidFill>
           <a:ln>
             <a:noFill/>
@@ -10550,14 +11727,14 @@
       </p:sp>
       <p:sp>
         <p:nvSpPr>
-          <p:cNvPr id="9" name="TextBox 8"/>
+          <p:cNvPr id="10" name="TextBox 9"/>
           <p:cNvSpPr txBox="1"/>
           <p:nvPr/>
         </p:nvSpPr>
         <p:spPr>
           <a:xfrm>
-            <a:off x="868680" y="1682496"/>
-            <a:ext cx="10515600" cy="777240"/>
+            <a:off x="822960" y="1929384"/>
+            <a:ext cx="4846320" cy="457200"/>
           </a:xfrm>
           <a:prstGeom prst="rect">
             <a:avLst/>
@@ -10565,7 +11742,7 @@
           <a:noFill/>
         </p:spPr>
         <p:txBody>
-          <a:bodyPr wrap="square" anchor="ctr">
+          <a:bodyPr wrap="square" anchor="t">
             <a:spAutoFit/>
           </a:bodyPr>
           <a:lstStyle/>
@@ -10579,36 +11756,176 @@
               </a:spcAft>
             </a:pPr>
             <a:r>
-              <a:rPr sz="1600" b="1">
+              <a:rPr sz="1700" b="1">
+                <a:solidFill>
+                  <a:srgbClr val="FFFFFF"/>
+                </a:solidFill>
+                <a:latin typeface="맑은 고딕"/>
+              </a:rPr>
+              <a:t>temperature = 0  (결정적)</a:t>
+            </a:r>
+          </a:p>
+        </p:txBody>
+      </p:sp>
+      <p:sp>
+        <p:nvSpPr>
+          <p:cNvPr id="11" name="TextBox 10"/>
+          <p:cNvSpPr txBox="1"/>
+          <p:nvPr/>
+        </p:nvSpPr>
+        <p:spPr>
+          <a:xfrm>
+            <a:off x="822960" y="2578608"/>
+            <a:ext cx="4846320" cy="411480"/>
+          </a:xfrm>
+          <a:prstGeom prst="rect">
+            <a:avLst/>
+          </a:prstGeom>
+          <a:noFill/>
+        </p:spPr>
+        <p:txBody>
+          <a:bodyPr wrap="square" anchor="t">
+            <a:spAutoFit/>
+          </a:bodyPr>
+          <a:lstStyle/>
+          <a:p>
+            <a:pPr algn="l">
+              <a:lnSpc>
+                <a:spcPct val="105000"/>
+              </a:lnSpc>
+              <a:spcAft>
+                <a:spcPts val="600"/>
+              </a:spcAft>
+            </a:pPr>
+            <a:r>
+              <a:rPr sz="1400" b="1">
+                <a:solidFill>
+                  <a:srgbClr val="10B981"/>
+                </a:solidFill>
+                <a:latin typeface="맑은 고딕"/>
+              </a:rPr>
+              <a:t>같은 입력 = 항상 같은 답</a:t>
+            </a:r>
+          </a:p>
+        </p:txBody>
+      </p:sp>
+      <p:sp>
+        <p:nvSpPr>
+          <p:cNvPr id="12" name="TextBox 11"/>
+          <p:cNvSpPr txBox="1"/>
+          <p:nvPr/>
+        </p:nvSpPr>
+        <p:spPr>
+          <a:xfrm>
+            <a:off x="822960" y="3035808"/>
+            <a:ext cx="4892040" cy="1143000"/>
+          </a:xfrm>
+          <a:prstGeom prst="rect">
+            <a:avLst/>
+          </a:prstGeom>
+          <a:noFill/>
+        </p:spPr>
+        <p:txBody>
+          <a:bodyPr wrap="square" anchor="t">
+            <a:spAutoFit/>
+          </a:bodyPr>
+          <a:lstStyle/>
+          <a:p>
+            <a:pPr algn="l">
+              <a:lnSpc>
+                <a:spcPct val="105000"/>
+              </a:lnSpc>
+              <a:spcAft>
+                <a:spcPts val="700"/>
+              </a:spcAft>
+            </a:pPr>
+            <a:r>
+              <a:rPr sz="1300" b="1">
+                <a:solidFill>
+                  <a:srgbClr val="10B981"/>
+                </a:solidFill>
+                <a:latin typeface="맑은 고딕"/>
+              </a:rPr>
+              <a:t>· </a:t>
+            </a:r>
+            <a:r>
+              <a:rPr sz="1300" b="0">
                 <a:solidFill>
                   <a:srgbClr val="374151"/>
                 </a:solidFill>
                 <a:latin typeface="맑은 고딕"/>
               </a:rPr>
-              <a:t>• 방향과 취향은 사람 몫</a:t>
-            </a:r>
-            <a:r>
-              <a:rPr sz="1400" b="0">
-                <a:solidFill>
-                  <a:srgbClr val="6B7280"/>
-                </a:solidFill>
-                <a:latin typeface="맑은 고딕"/>
-              </a:rPr>
-              <a:t>   —  "어떤 기능이 필요한가", "이 화면이 임원에게 와닿는가"는 AI가 정해주지 않음</a:t>
-            </a:r>
-          </a:p>
-        </p:txBody>
-      </p:sp>
-      <p:sp>
-        <p:nvSpPr>
-          <p:cNvPr id="10" name="Rectangle 9"/>
+              <a:t>쓰는 곳: 경쟁력 분류·기준매핑, 업체 원인분석</a:t>
+            </a:r>
+          </a:p>
+          <a:p>
+            <a:pPr algn="l">
+              <a:lnSpc>
+                <a:spcPct val="105000"/>
+              </a:lnSpc>
+              <a:spcAft>
+                <a:spcPts val="700"/>
+              </a:spcAft>
+            </a:pPr>
+            <a:r>
+              <a:rPr sz="1300" b="1">
+                <a:solidFill>
+                  <a:srgbClr val="10B981"/>
+                </a:solidFill>
+                <a:latin typeface="맑은 고딕"/>
+              </a:rPr>
+              <a:t>· </a:t>
+            </a:r>
+            <a:r>
+              <a:rPr sz="1300" b="0">
+                <a:solidFill>
+                  <a:srgbClr val="374151"/>
+                </a:solidFill>
+                <a:latin typeface="맑은 고딕"/>
+              </a:rPr>
+              <a:t>효과: 보고서 신뢰 + 캐시로 LLM 재호출 0회(비용↓)</a:t>
+            </a:r>
+          </a:p>
+          <a:p>
+            <a:pPr algn="l">
+              <a:lnSpc>
+                <a:spcPct val="105000"/>
+              </a:lnSpc>
+              <a:spcAft>
+                <a:spcPts val="700"/>
+              </a:spcAft>
+            </a:pPr>
+            <a:r>
+              <a:rPr sz="1300" b="1">
+                <a:solidFill>
+                  <a:srgbClr val="10B981"/>
+                </a:solidFill>
+                <a:latin typeface="맑은 고딕"/>
+              </a:rPr>
+              <a:t>· </a:t>
+            </a:r>
+            <a:r>
+              <a:rPr sz="1300" b="0">
+                <a:solidFill>
+                  <a:srgbClr val="374151"/>
+                </a:solidFill>
+                <a:latin typeface="맑은 고딕"/>
+              </a:rPr>
+              <a:t>숫자 보정 로직과도 안 어긋남</a:t>
+            </a:r>
+          </a:p>
+        </p:txBody>
+      </p:sp>
+      <p:sp>
+        <p:nvSpPr>
+          <p:cNvPr id="13" name="Rectangle 12"/>
           <p:cNvSpPr/>
           <p:nvPr/>
         </p:nvSpPr>
         <p:spPr>
           <a:xfrm>
-            <a:off x="548640" y="2670048"/>
-            <a:ext cx="11091672" cy="1005840"/>
+            <a:off x="6263640" y="1828800"/>
+            <a:ext cx="5376672" cy="2377440"/>
           </a:xfrm>
           <a:prstGeom prst="rect">
             <a:avLst/>
@@ -10647,20 +11964,20 @@
       </p:sp>
       <p:sp>
         <p:nvSpPr>
-          <p:cNvPr id="11" name="Rectangle 10"/>
+          <p:cNvPr id="14" name="Rectangle 13"/>
           <p:cNvSpPr/>
           <p:nvPr/>
         </p:nvSpPr>
         <p:spPr>
           <a:xfrm>
-            <a:off x="548640" y="2670048"/>
-            <a:ext cx="76200" cy="1005840"/>
+            <a:off x="6263640" y="1828800"/>
+            <a:ext cx="5376672" cy="640080"/>
           </a:xfrm>
           <a:prstGeom prst="rect">
             <a:avLst/>
           </a:prstGeom>
           <a:solidFill>
-            <a:srgbClr val="F59E0B"/>
+            <a:srgbClr val="2563EB"/>
           </a:solidFill>
           <a:ln>
             <a:noFill/>
@@ -10691,14 +12008,14 @@
       </p:sp>
       <p:sp>
         <p:nvSpPr>
-          <p:cNvPr id="12" name="TextBox 11"/>
+          <p:cNvPr id="15" name="TextBox 14"/>
           <p:cNvSpPr txBox="1"/>
           <p:nvPr/>
         </p:nvSpPr>
         <p:spPr>
           <a:xfrm>
-            <a:off x="868680" y="2798064"/>
-            <a:ext cx="10515600" cy="777240"/>
+            <a:off x="6537960" y="1929384"/>
+            <a:ext cx="4846320" cy="457200"/>
           </a:xfrm>
           <a:prstGeom prst="rect">
             <a:avLst/>
@@ -10706,7 +12023,7 @@
           <a:noFill/>
         </p:spPr>
         <p:txBody>
-          <a:bodyPr wrap="square" anchor="ctr">
+          <a:bodyPr wrap="square" anchor="t">
             <a:spAutoFit/>
           </a:bodyPr>
           <a:lstStyle/>
@@ -10720,126 +12037,27 @@
               </a:spcAft>
             </a:pPr>
             <a:r>
-              <a:rPr sz="1600" b="1">
-                <a:solidFill>
-                  <a:srgbClr val="374151"/>
-                </a:solidFill>
-                <a:latin typeface="맑은 고딕"/>
-              </a:rPr>
-              <a:t>• 도메인 판단은 사람이</a:t>
-            </a:r>
-            <a:r>
-              <a:rPr sz="1400" b="0">
-                <a:solidFill>
-                  <a:srgbClr val="6B7280"/>
-                </a:solidFill>
-                <a:latin typeface="맑은 고딕"/>
-              </a:rPr>
-              <a:t>   —  같은 회사가 스토어마다 다른 이름으로 등록된 경우를 합치는 규칙은 사람이 정의</a:t>
-            </a:r>
-          </a:p>
-        </p:txBody>
-      </p:sp>
-      <p:sp>
-        <p:nvSpPr>
-          <p:cNvPr id="13" name="Rectangle 12"/>
-          <p:cNvSpPr/>
-          <p:nvPr/>
-        </p:nvSpPr>
-        <p:spPr>
-          <a:xfrm>
-            <a:off x="548640" y="3785616"/>
-            <a:ext cx="11091672" cy="1005840"/>
-          </a:xfrm>
-          <a:prstGeom prst="rect">
-            <a:avLst/>
-          </a:prstGeom>
-          <a:solidFill>
-            <a:srgbClr val="FFFFFF"/>
-          </a:solidFill>
-          <a:ln w="12700">
-            <a:solidFill>
-              <a:srgbClr val="E2E8F0"/>
-            </a:solidFill>
-          </a:ln>
-          <a:effectLst/>
-        </p:spPr>
-        <p:style>
-          <a:lnRef idx="1">
-            <a:schemeClr val="accent1"/>
-          </a:lnRef>
-          <a:fillRef idx="3">
-            <a:schemeClr val="accent1"/>
-          </a:fillRef>
-          <a:effectRef idx="2">
-            <a:schemeClr val="accent1"/>
-          </a:effectRef>
-          <a:fontRef idx="minor">
-            <a:schemeClr val="lt1"/>
-          </a:fontRef>
-        </p:style>
-        <p:txBody>
-          <a:bodyPr rtlCol="0" anchor="ctr"/>
-          <a:lstStyle/>
-          <a:p>
-            <a:pPr algn="ctr"/>
-          </a:p>
-        </p:txBody>
-      </p:sp>
-      <p:sp>
-        <p:nvSpPr>
-          <p:cNvPr id="14" name="Rectangle 13"/>
-          <p:cNvSpPr/>
-          <p:nvPr/>
-        </p:nvSpPr>
-        <p:spPr>
-          <a:xfrm>
-            <a:off x="548640" y="3785616"/>
-            <a:ext cx="76200" cy="1005840"/>
-          </a:xfrm>
-          <a:prstGeom prst="rect">
-            <a:avLst/>
-          </a:prstGeom>
-          <a:solidFill>
-            <a:srgbClr val="F59E0B"/>
-          </a:solidFill>
-          <a:ln>
-            <a:noFill/>
-          </a:ln>
-          <a:effectLst/>
-        </p:spPr>
-        <p:style>
-          <a:lnRef idx="1">
-            <a:schemeClr val="accent1"/>
-          </a:lnRef>
-          <a:fillRef idx="3">
-            <a:schemeClr val="accent1"/>
-          </a:fillRef>
-          <a:effectRef idx="2">
-            <a:schemeClr val="accent1"/>
-          </a:effectRef>
-          <a:fontRef idx="minor">
-            <a:schemeClr val="lt1"/>
-          </a:fontRef>
-        </p:style>
-        <p:txBody>
-          <a:bodyPr rtlCol="0" anchor="ctr"/>
-          <a:lstStyle/>
-          <a:p>
-            <a:pPr algn="ctr"/>
-          </a:p>
-        </p:txBody>
-      </p:sp>
-      <p:sp>
-        <p:nvSpPr>
-          <p:cNvPr id="15" name="TextBox 14"/>
+              <a:rPr sz="1700" b="1">
+                <a:solidFill>
+                  <a:srgbClr val="FFFFFF"/>
+                </a:solidFill>
+                <a:latin typeface="맑은 고딕"/>
+              </a:rPr>
+              <a:t>기본값 ≈ 1.0  (다양성)</a:t>
+            </a:r>
+          </a:p>
+        </p:txBody>
+      </p:sp>
+      <p:sp>
+        <p:nvSpPr>
+          <p:cNvPr id="16" name="TextBox 15"/>
           <p:cNvSpPr txBox="1"/>
           <p:nvPr/>
         </p:nvSpPr>
         <p:spPr>
           <a:xfrm>
-            <a:off x="868680" y="3913632"/>
-            <a:ext cx="10515600" cy="777240"/>
+            <a:off x="6537960" y="2578608"/>
+            <a:ext cx="4846320" cy="411480"/>
           </a:xfrm>
           <a:prstGeom prst="rect">
             <a:avLst/>
@@ -10847,7 +12065,7 @@
           <a:noFill/>
         </p:spPr>
         <p:txBody>
-          <a:bodyPr wrap="square" anchor="ctr">
+          <a:bodyPr wrap="square" anchor="t">
             <a:spAutoFit/>
           </a:bodyPr>
           <a:lstStyle/>
@@ -10861,47 +12079,143 @@
               </a:spcAft>
             </a:pPr>
             <a:r>
-              <a:rPr sz="1600" b="1">
+              <a:rPr sz="1400" b="1">
+                <a:solidFill>
+                  <a:srgbClr val="2563EB"/>
+                </a:solidFill>
+                <a:latin typeface="맑은 고딕"/>
+              </a:rPr>
+              <a:t>표현이 매번 조금 달라짐</a:t>
+            </a:r>
+          </a:p>
+        </p:txBody>
+      </p:sp>
+      <p:sp>
+        <p:nvSpPr>
+          <p:cNvPr id="17" name="TextBox 16"/>
+          <p:cNvSpPr txBox="1"/>
+          <p:nvPr/>
+        </p:nvSpPr>
+        <p:spPr>
+          <a:xfrm>
+            <a:off x="6537960" y="3035808"/>
+            <a:ext cx="4892040" cy="1143000"/>
+          </a:xfrm>
+          <a:prstGeom prst="rect">
+            <a:avLst/>
+          </a:prstGeom>
+          <a:noFill/>
+        </p:spPr>
+        <p:txBody>
+          <a:bodyPr wrap="square" anchor="t">
+            <a:spAutoFit/>
+          </a:bodyPr>
+          <a:lstStyle/>
+          <a:p>
+            <a:pPr algn="l">
+              <a:lnSpc>
+                <a:spcPct val="105000"/>
+              </a:lnSpc>
+              <a:spcAft>
+                <a:spcPts val="700"/>
+              </a:spcAft>
+            </a:pPr>
+            <a:r>
+              <a:rPr sz="1300" b="1">
+                <a:solidFill>
+                  <a:srgbClr val="2563EB"/>
+                </a:solidFill>
+                <a:latin typeface="맑은 고딕"/>
+              </a:rPr>
+              <a:t>· </a:t>
+            </a:r>
+            <a:r>
+              <a:rPr sz="1300" b="0">
                 <a:solidFill>
                   <a:srgbClr val="374151"/>
                 </a:solidFill>
                 <a:latin typeface="맑은 고딕"/>
               </a:rPr>
-              <a:t>• 검증 없이는 위험</a:t>
-            </a:r>
-            <a:r>
-              <a:rPr sz="1400" b="0">
-                <a:solidFill>
-                  <a:srgbClr val="6B7280"/>
-                </a:solidFill>
-                <a:latin typeface="맑은 고딕"/>
-              </a:rPr>
-              <a:t>   —  AI 결과물은 반드시 테스트·사람 검토. 그래서 자동 테스트 19종을 함께 운영</a:t>
-            </a:r>
-          </a:p>
-        </p:txBody>
-      </p:sp>
-      <p:sp>
-        <p:nvSpPr>
-          <p:cNvPr id="16" name="Rectangle 15"/>
+              <a:t>쓰는 곳: 리뷰 번역, 마인드맵, 자동 카테고리 도출</a:t>
+            </a:r>
+          </a:p>
+          <a:p>
+            <a:pPr algn="l">
+              <a:lnSpc>
+                <a:spcPct val="105000"/>
+              </a:lnSpc>
+              <a:spcAft>
+                <a:spcPts val="700"/>
+              </a:spcAft>
+            </a:pPr>
+            <a:r>
+              <a:rPr sz="1300" b="1">
+                <a:solidFill>
+                  <a:srgbClr val="2563EB"/>
+                </a:solidFill>
+                <a:latin typeface="맑은 고딕"/>
+              </a:rPr>
+              <a:t>· </a:t>
+            </a:r>
+            <a:r>
+              <a:rPr sz="1300" b="0">
+                <a:solidFill>
+                  <a:srgbClr val="374151"/>
+                </a:solidFill>
+                <a:latin typeface="맑은 고딕"/>
+              </a:rPr>
+              <a:t>효과: 더 자연스러운 문장·표현</a:t>
+            </a:r>
+          </a:p>
+          <a:p>
+            <a:pPr algn="l">
+              <a:lnSpc>
+                <a:spcPct val="105000"/>
+              </a:lnSpc>
+              <a:spcAft>
+                <a:spcPts val="700"/>
+              </a:spcAft>
+            </a:pPr>
+            <a:r>
+              <a:rPr sz="1300" b="1">
+                <a:solidFill>
+                  <a:srgbClr val="2563EB"/>
+                </a:solidFill>
+                <a:latin typeface="맑은 고딕"/>
+              </a:rPr>
+              <a:t>· </a:t>
+            </a:r>
+            <a:r>
+              <a:rPr sz="1300" b="0">
+                <a:solidFill>
+                  <a:srgbClr val="374151"/>
+                </a:solidFill>
+                <a:latin typeface="맑은 고딕"/>
+              </a:rPr>
+              <a:t>읽기·탐색용이라 재현성 부담이 작음</a:t>
+            </a:r>
+          </a:p>
+        </p:txBody>
+      </p:sp>
+      <p:sp>
+        <p:nvSpPr>
+          <p:cNvPr id="18" name="Rectangle 17"/>
           <p:cNvSpPr/>
           <p:nvPr/>
         </p:nvSpPr>
         <p:spPr>
           <a:xfrm>
-            <a:off x="548640" y="4901184"/>
-            <a:ext cx="11091672" cy="1005840"/>
+            <a:off x="548640" y="4434840"/>
+            <a:ext cx="11091672" cy="1417320"/>
           </a:xfrm>
           <a:prstGeom prst="rect">
             <a:avLst/>
           </a:prstGeom>
           <a:solidFill>
-            <a:srgbClr val="FFFFFF"/>
+            <a:srgbClr val="1F2937"/>
           </a:solidFill>
-          <a:ln w="12700">
-            <a:solidFill>
-              <a:srgbClr val="E2E8F0"/>
-            </a:solidFill>
+          <a:ln>
+            <a:noFill/>
           </a:ln>
           <a:effectLst/>
         </p:spPr>
@@ -10929,58 +12243,14 @@
       </p:sp>
       <p:sp>
         <p:nvSpPr>
-          <p:cNvPr id="17" name="Rectangle 16"/>
-          <p:cNvSpPr/>
-          <p:nvPr/>
-        </p:nvSpPr>
-        <p:spPr>
-          <a:xfrm>
-            <a:off x="548640" y="4901184"/>
-            <a:ext cx="76200" cy="1005840"/>
-          </a:xfrm>
-          <a:prstGeom prst="rect">
-            <a:avLst/>
-          </a:prstGeom>
-          <a:solidFill>
-            <a:srgbClr val="F59E0B"/>
-          </a:solidFill>
-          <a:ln>
-            <a:noFill/>
-          </a:ln>
-          <a:effectLst/>
-        </p:spPr>
-        <p:style>
-          <a:lnRef idx="1">
-            <a:schemeClr val="accent1"/>
-          </a:lnRef>
-          <a:fillRef idx="3">
-            <a:schemeClr val="accent1"/>
-          </a:fillRef>
-          <a:effectRef idx="2">
-            <a:schemeClr val="accent1"/>
-          </a:effectRef>
-          <a:fontRef idx="minor">
-            <a:schemeClr val="lt1"/>
-          </a:fontRef>
-        </p:style>
-        <p:txBody>
-          <a:bodyPr rtlCol="0" anchor="ctr"/>
-          <a:lstStyle/>
-          <a:p>
-            <a:pPr algn="ctr"/>
-          </a:p>
-        </p:txBody>
-      </p:sp>
-      <p:sp>
-        <p:nvSpPr>
-          <p:cNvPr id="18" name="TextBox 17"/>
+          <p:cNvPr id="19" name="TextBox 18"/>
           <p:cNvSpPr txBox="1"/>
           <p:nvPr/>
         </p:nvSpPr>
         <p:spPr>
           <a:xfrm>
-            <a:off x="868680" y="5029200"/>
-            <a:ext cx="10515600" cy="777240"/>
+            <a:off x="868680" y="4572000"/>
+            <a:ext cx="10515600" cy="1188720"/>
           </a:xfrm>
           <a:prstGeom prst="rect">
             <a:avLst/>
@@ -10988,7 +12258,7 @@
           <a:noFill/>
         </p:spPr>
         <p:txBody>
-          <a:bodyPr wrap="square" anchor="ctr">
+          <a:bodyPr wrap="square" anchor="t">
             <a:spAutoFit/>
           </a:bodyPr>
           <a:lstStyle/>
@@ -10998,33 +12268,89 @@
                 <a:spcPct val="105000"/>
               </a:lnSpc>
               <a:spcAft>
-                <a:spcPts val="600"/>
+                <a:spcPts val="800"/>
               </a:spcAft>
             </a:pPr>
             <a:r>
-              <a:rPr sz="1600" b="1">
-                <a:solidFill>
-                  <a:srgbClr val="374151"/>
-                </a:solidFill>
-                <a:latin typeface="맑은 고딕"/>
-              </a:rPr>
-              <a:t>• 보안·비용은 설계 사항</a:t>
-            </a:r>
-            <a:r>
-              <a:rPr sz="1400" b="0">
-                <a:solidFill>
-                  <a:srgbClr val="6B7280"/>
-                </a:solidFill>
-                <a:latin typeface="맑은 고딕"/>
-              </a:rPr>
-              <a:t>   —  무단 사용을 막는 접근 장치, 비용 통제는 사람이 의도적으로 넣음</a:t>
-            </a:r>
-          </a:p>
-        </p:txBody>
-      </p:sp>
-      <p:sp>
-        <p:nvSpPr>
-          <p:cNvPr id="19" name="TextBox 18"/>
+              <a:rPr sz="1400" b="1">
+                <a:solidFill>
+                  <a:srgbClr val="10B981"/>
+                </a:solidFill>
+                <a:latin typeface="맑은 고딕"/>
+              </a:rPr>
+              <a:t>예시 — 경쟁력 분석에 같은 엑셀을 다시 업로드하면?</a:t>
+            </a:r>
+          </a:p>
+          <a:p>
+            <a:pPr algn="l">
+              <a:lnSpc>
+                <a:spcPct val="105000"/>
+              </a:lnSpc>
+              <a:spcAft>
+                <a:spcPts val="800"/>
+              </a:spcAft>
+            </a:pPr>
+            <a:r>
+              <a:rPr sz="1500" b="1">
+                <a:solidFill>
+                  <a:srgbClr val="6EE7B7"/>
+                </a:solidFill>
+                <a:latin typeface="맑은 고딕"/>
+              </a:rPr>
+              <a:t>0: </a:t>
+            </a:r>
+            <a:r>
+              <a:rPr sz="1500" b="0">
+                <a:solidFill>
+                  <a:srgbClr val="FFFFFF"/>
+                </a:solidFill>
+                <a:latin typeface="맑은 고딕"/>
+              </a:rPr>
+              <a:t>글자까지 똑같은 12개 카테고리·숫자 → 캐시 적중(재호출 0회)    </a:t>
+            </a:r>
+            <a:r>
+              <a:rPr sz="1500" b="1">
+                <a:solidFill>
+                  <a:srgbClr val="FCA5A5"/>
+                </a:solidFill>
+                <a:latin typeface="맑은 고딕"/>
+              </a:rPr>
+              <a:t>높으면: </a:t>
+            </a:r>
+            <a:r>
+              <a:rPr sz="1500" b="0">
+                <a:solidFill>
+                  <a:srgbClr val="FFFFFF"/>
+                </a:solidFill>
+                <a:latin typeface="맑은 고딕"/>
+              </a:rPr>
+              <a:t>카테고리 수·분류·숫자가 출렁 → "어제 PPT랑 왜 달라요?"</a:t>
+            </a:r>
+          </a:p>
+          <a:p>
+            <a:pPr algn="l">
+              <a:lnSpc>
+                <a:spcPct val="105000"/>
+              </a:lnSpc>
+              <a:spcAft>
+                <a:spcPts val="800"/>
+              </a:spcAft>
+            </a:pPr>
+            <a:r>
+              <a:rPr sz="1400" b="1">
+                <a:solidFill>
+                  <a:srgbClr val="93C5FD"/>
+                </a:solidFill>
+                <a:latin typeface="맑은 고딕"/>
+              </a:rPr>
+              <a:t>정리: 숫자로 집계·저장·공유하는 작업 → 0 / 읽기·탐색용 생성 작업 → 기본값</a:t>
+            </a:r>
+          </a:p>
+        </p:txBody>
+      </p:sp>
+      <p:sp>
+        <p:nvSpPr>
+          <p:cNvPr id="20" name="TextBox 19"/>
           <p:cNvSpPr txBox="1"/>
           <p:nvPr/>
         </p:nvSpPr>
@@ -11251,7 +12577,7 @@
                 </a:solidFill>
                 <a:latin typeface="맑은 고딕"/>
               </a:rPr>
-              <a:t>숫자로 보는 결과</a:t>
+              <a:t>신뢰받는 발표는 한계도 말한다</a:t>
             </a:r>
           </a:p>
         </p:txBody>
@@ -11293,7 +12619,7 @@
                 </a:solidFill>
                 <a:latin typeface="맑은 고딕"/>
               </a:rPr>
-              <a:t>1인 · 3주로 풀스택 서비스</a:t>
+              <a:t>AI가 "혼자" 못한 것</a:t>
             </a:r>
           </a:p>
         </p:txBody>
@@ -11307,7 +12633,7 @@
         <p:spPr>
           <a:xfrm>
             <a:off x="548640" y="1554480"/>
-            <a:ext cx="3566160" cy="1691640"/>
+            <a:ext cx="11091672" cy="1005840"/>
           </a:xfrm>
           <a:prstGeom prst="rect">
             <a:avLst/>
@@ -11346,14 +12672,58 @@
       </p:sp>
       <p:sp>
         <p:nvSpPr>
-          <p:cNvPr id="8" name="TextBox 7"/>
+          <p:cNvPr id="8" name="Rectangle 7"/>
+          <p:cNvSpPr/>
+          <p:nvPr/>
+        </p:nvSpPr>
+        <p:spPr>
+          <a:xfrm>
+            <a:off x="548640" y="1554480"/>
+            <a:ext cx="76200" cy="1005840"/>
+          </a:xfrm>
+          <a:prstGeom prst="rect">
+            <a:avLst/>
+          </a:prstGeom>
+          <a:solidFill>
+            <a:srgbClr val="F59E0B"/>
+          </a:solidFill>
+          <a:ln>
+            <a:noFill/>
+          </a:ln>
+          <a:effectLst/>
+        </p:spPr>
+        <p:style>
+          <a:lnRef idx="1">
+            <a:schemeClr val="accent1"/>
+          </a:lnRef>
+          <a:fillRef idx="3">
+            <a:schemeClr val="accent1"/>
+          </a:fillRef>
+          <a:effectRef idx="2">
+            <a:schemeClr val="accent1"/>
+          </a:effectRef>
+          <a:fontRef idx="minor">
+            <a:schemeClr val="lt1"/>
+          </a:fontRef>
+        </p:style>
+        <p:txBody>
+          <a:bodyPr rtlCol="0" anchor="ctr"/>
+          <a:lstStyle/>
+          <a:p>
+            <a:pPr algn="ctr"/>
+          </a:p>
+        </p:txBody>
+      </p:sp>
+      <p:sp>
+        <p:nvSpPr>
+          <p:cNvPr id="9" name="TextBox 8"/>
           <p:cNvSpPr txBox="1"/>
           <p:nvPr/>
         </p:nvSpPr>
         <p:spPr>
           <a:xfrm>
-            <a:off x="548640" y="1828800"/>
-            <a:ext cx="3566160" cy="822960"/>
+            <a:off x="868680" y="1682496"/>
+            <a:ext cx="10515600" cy="777240"/>
           </a:xfrm>
           <a:prstGeom prst="rect">
             <a:avLst/>
@@ -11361,12 +12731,12 @@
           <a:noFill/>
         </p:spPr>
         <p:txBody>
-          <a:bodyPr wrap="square" anchor="t">
+          <a:bodyPr wrap="square" anchor="ctr">
             <a:spAutoFit/>
           </a:bodyPr>
           <a:lstStyle/>
           <a:p>
-            <a:pPr algn="ctr">
+            <a:pPr algn="l">
               <a:lnSpc>
                 <a:spcPct val="105000"/>
               </a:lnSpc>
@@ -11375,55 +12745,22 @@
               </a:spcAft>
             </a:pPr>
             <a:r>
-              <a:rPr sz="4000" b="1">
-                <a:solidFill>
-                  <a:srgbClr val="2563EB"/>
-                </a:solidFill>
-                <a:latin typeface="맑은 고딕"/>
-              </a:rPr>
-              <a:t>3주</a:t>
-            </a:r>
-          </a:p>
-        </p:txBody>
-      </p:sp>
-      <p:sp>
-        <p:nvSpPr>
-          <p:cNvPr id="9" name="TextBox 8"/>
-          <p:cNvSpPr txBox="1"/>
-          <p:nvPr/>
-        </p:nvSpPr>
-        <p:spPr>
-          <a:xfrm>
-            <a:off x="548640" y="2651760"/>
-            <a:ext cx="3566160" cy="457200"/>
-          </a:xfrm>
-          <a:prstGeom prst="rect">
-            <a:avLst/>
-          </a:prstGeom>
-          <a:noFill/>
-        </p:spPr>
-        <p:txBody>
-          <a:bodyPr wrap="square" anchor="t">
-            <a:spAutoFit/>
-          </a:bodyPr>
-          <a:lstStyle/>
-          <a:p>
-            <a:pPr algn="ctr">
-              <a:lnSpc>
-                <a:spcPct val="105000"/>
-              </a:lnSpc>
-              <a:spcAft>
-                <a:spcPts val="600"/>
-              </a:spcAft>
-            </a:pPr>
+              <a:rPr sz="1600" b="1">
+                <a:solidFill>
+                  <a:srgbClr val="374151"/>
+                </a:solidFill>
+                <a:latin typeface="맑은 고딕"/>
+              </a:rPr>
+              <a:t>• 방향과 취향은 사람 몫</a:t>
+            </a:r>
             <a:r>
               <a:rPr sz="1400" b="0">
                 <a:solidFill>
-                  <a:srgbClr val="374151"/>
-                </a:solidFill>
-                <a:latin typeface="맑은 고딕"/>
-              </a:rPr>
-              <a:t>개발 기간 (실작업 9일)</a:t>
+                  <a:srgbClr val="6B7280"/>
+                </a:solidFill>
+                <a:latin typeface="맑은 고딕"/>
+              </a:rPr>
+              <a:t>   —  "어떤 기능이 필요한가", "이 화면이 임원에게 와닿는가"는 AI가 정해주지 않음</a:t>
             </a:r>
           </a:p>
         </p:txBody>
@@ -11436,8 +12773,8 @@
         </p:nvSpPr>
         <p:spPr>
           <a:xfrm>
-            <a:off x="4315968" y="1554480"/>
-            <a:ext cx="3566160" cy="1691640"/>
+            <a:off x="548640" y="2670048"/>
+            <a:ext cx="11091672" cy="1005840"/>
           </a:xfrm>
           <a:prstGeom prst="rect">
             <a:avLst/>
@@ -11476,14 +12813,58 @@
       </p:sp>
       <p:sp>
         <p:nvSpPr>
-          <p:cNvPr id="11" name="TextBox 10"/>
+          <p:cNvPr id="11" name="Rectangle 10"/>
+          <p:cNvSpPr/>
+          <p:nvPr/>
+        </p:nvSpPr>
+        <p:spPr>
+          <a:xfrm>
+            <a:off x="548640" y="2670048"/>
+            <a:ext cx="76200" cy="1005840"/>
+          </a:xfrm>
+          <a:prstGeom prst="rect">
+            <a:avLst/>
+          </a:prstGeom>
+          <a:solidFill>
+            <a:srgbClr val="F59E0B"/>
+          </a:solidFill>
+          <a:ln>
+            <a:noFill/>
+          </a:ln>
+          <a:effectLst/>
+        </p:spPr>
+        <p:style>
+          <a:lnRef idx="1">
+            <a:schemeClr val="accent1"/>
+          </a:lnRef>
+          <a:fillRef idx="3">
+            <a:schemeClr val="accent1"/>
+          </a:fillRef>
+          <a:effectRef idx="2">
+            <a:schemeClr val="accent1"/>
+          </a:effectRef>
+          <a:fontRef idx="minor">
+            <a:schemeClr val="lt1"/>
+          </a:fontRef>
+        </p:style>
+        <p:txBody>
+          <a:bodyPr rtlCol="0" anchor="ctr"/>
+          <a:lstStyle/>
+          <a:p>
+            <a:pPr algn="ctr"/>
+          </a:p>
+        </p:txBody>
+      </p:sp>
+      <p:sp>
+        <p:nvSpPr>
+          <p:cNvPr id="12" name="TextBox 11"/>
           <p:cNvSpPr txBox="1"/>
           <p:nvPr/>
         </p:nvSpPr>
         <p:spPr>
           <a:xfrm>
-            <a:off x="4315968" y="1828800"/>
-            <a:ext cx="3566160" cy="822960"/>
+            <a:off x="868680" y="2798064"/>
+            <a:ext cx="10515600" cy="777240"/>
           </a:xfrm>
           <a:prstGeom prst="rect">
             <a:avLst/>
@@ -11491,12 +12872,12 @@
           <a:noFill/>
         </p:spPr>
         <p:txBody>
-          <a:bodyPr wrap="square" anchor="t">
+          <a:bodyPr wrap="square" anchor="ctr">
             <a:spAutoFit/>
           </a:bodyPr>
           <a:lstStyle/>
           <a:p>
-            <a:pPr algn="ctr">
+            <a:pPr algn="l">
               <a:lnSpc>
                 <a:spcPct val="105000"/>
               </a:lnSpc>
@@ -11505,55 +12886,22 @@
               </a:spcAft>
             </a:pPr>
             <a:r>
-              <a:rPr sz="4000" b="1">
-                <a:solidFill>
-                  <a:srgbClr val="2563EB"/>
-                </a:solidFill>
-                <a:latin typeface="맑은 고딕"/>
-              </a:rPr>
-              <a:t>50회</a:t>
-            </a:r>
-          </a:p>
-        </p:txBody>
-      </p:sp>
-      <p:sp>
-        <p:nvSpPr>
-          <p:cNvPr id="12" name="TextBox 11"/>
-          <p:cNvSpPr txBox="1"/>
-          <p:nvPr/>
-        </p:nvSpPr>
-        <p:spPr>
-          <a:xfrm>
-            <a:off x="4315968" y="2651760"/>
-            <a:ext cx="3566160" cy="457200"/>
-          </a:xfrm>
-          <a:prstGeom prst="rect">
-            <a:avLst/>
-          </a:prstGeom>
-          <a:noFill/>
-        </p:spPr>
-        <p:txBody>
-          <a:bodyPr wrap="square" anchor="t">
-            <a:spAutoFit/>
-          </a:bodyPr>
-          <a:lstStyle/>
-          <a:p>
-            <a:pPr algn="ctr">
-              <a:lnSpc>
-                <a:spcPct val="105000"/>
-              </a:lnSpc>
-              <a:spcAft>
-                <a:spcPts val="600"/>
-              </a:spcAft>
-            </a:pPr>
+              <a:rPr sz="1600" b="1">
+                <a:solidFill>
+                  <a:srgbClr val="374151"/>
+                </a:solidFill>
+                <a:latin typeface="맑은 고딕"/>
+              </a:rPr>
+              <a:t>• 도메인 판단은 사람이</a:t>
+            </a:r>
             <a:r>
               <a:rPr sz="1400" b="0">
                 <a:solidFill>
-                  <a:srgbClr val="374151"/>
-                </a:solidFill>
-                <a:latin typeface="맑은 고딕"/>
-              </a:rPr>
-              <a:t>개선 횟수(커밋)</a:t>
+                  <a:srgbClr val="6B7280"/>
+                </a:solidFill>
+                <a:latin typeface="맑은 고딕"/>
+              </a:rPr>
+              <a:t>   —  같은 회사가 스토어마다 다른 이름으로 등록된 경우를 합치는 규칙은 사람이 정의</a:t>
             </a:r>
           </a:p>
         </p:txBody>
@@ -11566,8 +12914,8 @@
         </p:nvSpPr>
         <p:spPr>
           <a:xfrm>
-            <a:off x="8083296" y="1554480"/>
-            <a:ext cx="3566160" cy="1691640"/>
+            <a:off x="548640" y="3785616"/>
+            <a:ext cx="11091672" cy="1005840"/>
           </a:xfrm>
           <a:prstGeom prst="rect">
             <a:avLst/>
@@ -11606,14 +12954,58 @@
       </p:sp>
       <p:sp>
         <p:nvSpPr>
-          <p:cNvPr id="14" name="TextBox 13"/>
+          <p:cNvPr id="14" name="Rectangle 13"/>
+          <p:cNvSpPr/>
+          <p:nvPr/>
+        </p:nvSpPr>
+        <p:spPr>
+          <a:xfrm>
+            <a:off x="548640" y="3785616"/>
+            <a:ext cx="76200" cy="1005840"/>
+          </a:xfrm>
+          <a:prstGeom prst="rect">
+            <a:avLst/>
+          </a:prstGeom>
+          <a:solidFill>
+            <a:srgbClr val="F59E0B"/>
+          </a:solidFill>
+          <a:ln>
+            <a:noFill/>
+          </a:ln>
+          <a:effectLst/>
+        </p:spPr>
+        <p:style>
+          <a:lnRef idx="1">
+            <a:schemeClr val="accent1"/>
+          </a:lnRef>
+          <a:fillRef idx="3">
+            <a:schemeClr val="accent1"/>
+          </a:fillRef>
+          <a:effectRef idx="2">
+            <a:schemeClr val="accent1"/>
+          </a:effectRef>
+          <a:fontRef idx="minor">
+            <a:schemeClr val="lt1"/>
+          </a:fontRef>
+        </p:style>
+        <p:txBody>
+          <a:bodyPr rtlCol="0" anchor="ctr"/>
+          <a:lstStyle/>
+          <a:p>
+            <a:pPr algn="ctr"/>
+          </a:p>
+        </p:txBody>
+      </p:sp>
+      <p:sp>
+        <p:nvSpPr>
+          <p:cNvPr id="15" name="TextBox 14"/>
           <p:cNvSpPr txBox="1"/>
           <p:nvPr/>
         </p:nvSpPr>
         <p:spPr>
           <a:xfrm>
-            <a:off x="8083296" y="1828800"/>
-            <a:ext cx="3566160" cy="822960"/>
+            <a:off x="868680" y="3913632"/>
+            <a:ext cx="10515600" cy="777240"/>
           </a:xfrm>
           <a:prstGeom prst="rect">
             <a:avLst/>
@@ -11621,12 +13013,12 @@
           <a:noFill/>
         </p:spPr>
         <p:txBody>
-          <a:bodyPr wrap="square" anchor="t">
+          <a:bodyPr wrap="square" anchor="ctr">
             <a:spAutoFit/>
           </a:bodyPr>
           <a:lstStyle/>
           <a:p>
-            <a:pPr algn="ctr">
+            <a:pPr algn="l">
               <a:lnSpc>
                 <a:spcPct val="105000"/>
               </a:lnSpc>
@@ -11635,55 +13027,22 @@
               </a:spcAft>
             </a:pPr>
             <a:r>
-              <a:rPr sz="4000" b="1">
-                <a:solidFill>
-                  <a:srgbClr val="2563EB"/>
-                </a:solidFill>
-                <a:latin typeface="맑은 고딕"/>
-              </a:rPr>
-              <a:t>2.3만 줄</a:t>
-            </a:r>
-          </a:p>
-        </p:txBody>
-      </p:sp>
-      <p:sp>
-        <p:nvSpPr>
-          <p:cNvPr id="15" name="TextBox 14"/>
-          <p:cNvSpPr txBox="1"/>
-          <p:nvPr/>
-        </p:nvSpPr>
-        <p:spPr>
-          <a:xfrm>
-            <a:off x="8083296" y="2651760"/>
-            <a:ext cx="3566160" cy="457200"/>
-          </a:xfrm>
-          <a:prstGeom prst="rect">
-            <a:avLst/>
-          </a:prstGeom>
-          <a:noFill/>
-        </p:spPr>
-        <p:txBody>
-          <a:bodyPr wrap="square" anchor="t">
-            <a:spAutoFit/>
-          </a:bodyPr>
-          <a:lstStyle/>
-          <a:p>
-            <a:pPr algn="ctr">
-              <a:lnSpc>
-                <a:spcPct val="105000"/>
-              </a:lnSpc>
-              <a:spcAft>
-                <a:spcPts val="600"/>
-              </a:spcAft>
-            </a:pPr>
+              <a:rPr sz="1600" b="1">
+                <a:solidFill>
+                  <a:srgbClr val="374151"/>
+                </a:solidFill>
+                <a:latin typeface="맑은 고딕"/>
+              </a:rPr>
+              <a:t>• 검증 없이는 위험</a:t>
+            </a:r>
             <a:r>
               <a:rPr sz="1400" b="0">
                 <a:solidFill>
-                  <a:srgbClr val="374151"/>
-                </a:solidFill>
-                <a:latin typeface="맑은 고딕"/>
-              </a:rPr>
-              <a:t>코드 규모</a:t>
+                  <a:srgbClr val="6B7280"/>
+                </a:solidFill>
+                <a:latin typeface="맑은 고딕"/>
+              </a:rPr>
+              <a:t>   —  AI 결과물은 반드시 테스트·사람 검토. 그래서 자동 테스트 19종을 함께 운영</a:t>
             </a:r>
           </a:p>
         </p:txBody>
@@ -11696,8 +13055,8 @@
         </p:nvSpPr>
         <p:spPr>
           <a:xfrm>
-            <a:off x="548640" y="3520439"/>
-            <a:ext cx="3566160" cy="1691640"/>
+            <a:off x="548640" y="4901184"/>
+            <a:ext cx="11091672" cy="1005840"/>
           </a:xfrm>
           <a:prstGeom prst="rect">
             <a:avLst/>
@@ -11736,14 +13095,58 @@
       </p:sp>
       <p:sp>
         <p:nvSpPr>
-          <p:cNvPr id="17" name="TextBox 16"/>
+          <p:cNvPr id="17" name="Rectangle 16"/>
+          <p:cNvSpPr/>
+          <p:nvPr/>
+        </p:nvSpPr>
+        <p:spPr>
+          <a:xfrm>
+            <a:off x="548640" y="4901184"/>
+            <a:ext cx="76200" cy="1005840"/>
+          </a:xfrm>
+          <a:prstGeom prst="rect">
+            <a:avLst/>
+          </a:prstGeom>
+          <a:solidFill>
+            <a:srgbClr val="F59E0B"/>
+          </a:solidFill>
+          <a:ln>
+            <a:noFill/>
+          </a:ln>
+          <a:effectLst/>
+        </p:spPr>
+        <p:style>
+          <a:lnRef idx="1">
+            <a:schemeClr val="accent1"/>
+          </a:lnRef>
+          <a:fillRef idx="3">
+            <a:schemeClr val="accent1"/>
+          </a:fillRef>
+          <a:effectRef idx="2">
+            <a:schemeClr val="accent1"/>
+          </a:effectRef>
+          <a:fontRef idx="minor">
+            <a:schemeClr val="lt1"/>
+          </a:fontRef>
+        </p:style>
+        <p:txBody>
+          <a:bodyPr rtlCol="0" anchor="ctr"/>
+          <a:lstStyle/>
+          <a:p>
+            <a:pPr algn="ctr"/>
+          </a:p>
+        </p:txBody>
+      </p:sp>
+      <p:sp>
+        <p:nvSpPr>
+          <p:cNvPr id="18" name="TextBox 17"/>
           <p:cNvSpPr txBox="1"/>
           <p:nvPr/>
         </p:nvSpPr>
         <p:spPr>
           <a:xfrm>
-            <a:off x="548640" y="3794759"/>
-            <a:ext cx="3566160" cy="822960"/>
+            <a:off x="868680" y="5029200"/>
+            <a:ext cx="10515600" cy="777240"/>
           </a:xfrm>
           <a:prstGeom prst="rect">
             <a:avLst/>
@@ -11751,12 +13154,12 @@
           <a:noFill/>
         </p:spPr>
         <p:txBody>
-          <a:bodyPr wrap="square" anchor="t">
+          <a:bodyPr wrap="square" anchor="ctr">
             <a:spAutoFit/>
           </a:bodyPr>
           <a:lstStyle/>
           <a:p>
-            <a:pPr algn="ctr">
+            <a:pPr algn="l">
               <a:lnSpc>
                 <a:spcPct val="105000"/>
               </a:lnSpc>
@@ -11765,382 +13168,29 @@
               </a:spcAft>
             </a:pPr>
             <a:r>
-              <a:rPr sz="4000" b="1">
-                <a:solidFill>
-                  <a:srgbClr val="2563EB"/>
-                </a:solidFill>
-                <a:latin typeface="맑은 고딕"/>
-              </a:rPr>
-              <a:t>19종</a:t>
-            </a:r>
-          </a:p>
-        </p:txBody>
-      </p:sp>
-      <p:sp>
-        <p:nvSpPr>
-          <p:cNvPr id="18" name="TextBox 17"/>
-          <p:cNvSpPr txBox="1"/>
-          <p:nvPr/>
-        </p:nvSpPr>
-        <p:spPr>
-          <a:xfrm>
-            <a:off x="548640" y="4617719"/>
-            <a:ext cx="3566160" cy="457200"/>
-          </a:xfrm>
-          <a:prstGeom prst="rect">
-            <a:avLst/>
-          </a:prstGeom>
-          <a:noFill/>
-        </p:spPr>
-        <p:txBody>
-          <a:bodyPr wrap="square" anchor="t">
-            <a:spAutoFit/>
-          </a:bodyPr>
-          <a:lstStyle/>
-          <a:p>
-            <a:pPr algn="ctr">
-              <a:lnSpc>
-                <a:spcPct val="105000"/>
-              </a:lnSpc>
-              <a:spcAft>
-                <a:spcPts val="600"/>
-              </a:spcAft>
-            </a:pPr>
+              <a:rPr sz="1600" b="1">
+                <a:solidFill>
+                  <a:srgbClr val="374151"/>
+                </a:solidFill>
+                <a:latin typeface="맑은 고딕"/>
+              </a:rPr>
+              <a:t>• 보안·비용은 설계 사항</a:t>
+            </a:r>
             <a:r>
               <a:rPr sz="1400" b="0">
                 <a:solidFill>
-                  <a:srgbClr val="374151"/>
-                </a:solidFill>
-                <a:latin typeface="맑은 고딕"/>
-              </a:rPr>
-              <a:t>자동 테스트</a:t>
-            </a:r>
-          </a:p>
-        </p:txBody>
-      </p:sp>
-      <p:sp>
-        <p:nvSpPr>
-          <p:cNvPr id="19" name="Rectangle 18"/>
-          <p:cNvSpPr/>
-          <p:nvPr/>
-        </p:nvSpPr>
-        <p:spPr>
-          <a:xfrm>
-            <a:off x="4315968" y="3520439"/>
-            <a:ext cx="3566160" cy="1691640"/>
-          </a:xfrm>
-          <a:prstGeom prst="rect">
-            <a:avLst/>
-          </a:prstGeom>
-          <a:solidFill>
-            <a:srgbClr val="FFFFFF"/>
-          </a:solidFill>
-          <a:ln w="12700">
-            <a:solidFill>
-              <a:srgbClr val="E2E8F0"/>
-            </a:solidFill>
-          </a:ln>
-          <a:effectLst/>
-        </p:spPr>
-        <p:style>
-          <a:lnRef idx="1">
-            <a:schemeClr val="accent1"/>
-          </a:lnRef>
-          <a:fillRef idx="3">
-            <a:schemeClr val="accent1"/>
-          </a:fillRef>
-          <a:effectRef idx="2">
-            <a:schemeClr val="accent1"/>
-          </a:effectRef>
-          <a:fontRef idx="minor">
-            <a:schemeClr val="lt1"/>
-          </a:fontRef>
-        </p:style>
-        <p:txBody>
-          <a:bodyPr rtlCol="0" anchor="ctr"/>
-          <a:lstStyle/>
-          <a:p>
-            <a:pPr algn="ctr"/>
-          </a:p>
-        </p:txBody>
-      </p:sp>
-      <p:sp>
-        <p:nvSpPr>
-          <p:cNvPr id="20" name="TextBox 19"/>
-          <p:cNvSpPr txBox="1"/>
-          <p:nvPr/>
-        </p:nvSpPr>
-        <p:spPr>
-          <a:xfrm>
-            <a:off x="4315968" y="3794759"/>
-            <a:ext cx="3566160" cy="822960"/>
-          </a:xfrm>
-          <a:prstGeom prst="rect">
-            <a:avLst/>
-          </a:prstGeom>
-          <a:noFill/>
-        </p:spPr>
-        <p:txBody>
-          <a:bodyPr wrap="square" anchor="t">
-            <a:spAutoFit/>
-          </a:bodyPr>
-          <a:lstStyle/>
-          <a:p>
-            <a:pPr algn="ctr">
-              <a:lnSpc>
-                <a:spcPct val="105000"/>
-              </a:lnSpc>
-              <a:spcAft>
-                <a:spcPts val="600"/>
-              </a:spcAft>
-            </a:pPr>
-            <a:r>
-              <a:rPr sz="4000" b="1">
-                <a:solidFill>
-                  <a:srgbClr val="2563EB"/>
-                </a:solidFill>
-                <a:latin typeface="맑은 고딕"/>
-              </a:rPr>
-              <a:t>4개</a:t>
-            </a:r>
-          </a:p>
-        </p:txBody>
-      </p:sp>
-      <p:sp>
-        <p:nvSpPr>
-          <p:cNvPr id="21" name="TextBox 20"/>
-          <p:cNvSpPr txBox="1"/>
-          <p:nvPr/>
-        </p:nvSpPr>
-        <p:spPr>
-          <a:xfrm>
-            <a:off x="4315968" y="4617719"/>
-            <a:ext cx="3566160" cy="457200"/>
-          </a:xfrm>
-          <a:prstGeom prst="rect">
-            <a:avLst/>
-          </a:prstGeom>
-          <a:noFill/>
-        </p:spPr>
-        <p:txBody>
-          <a:bodyPr wrap="square" anchor="t">
-            <a:spAutoFit/>
-          </a:bodyPr>
-          <a:lstStyle/>
-          <a:p>
-            <a:pPr algn="ctr">
-              <a:lnSpc>
-                <a:spcPct val="105000"/>
-              </a:lnSpc>
-              <a:spcAft>
-                <a:spcPts val="600"/>
-              </a:spcAft>
-            </a:pPr>
-            <a:r>
-              <a:rPr sz="1400" b="0">
-                <a:solidFill>
-                  <a:srgbClr val="374151"/>
-                </a:solidFill>
-                <a:latin typeface="맑은 고딕"/>
-              </a:rPr>
-              <a:t>연동 채널</a:t>
-            </a:r>
-          </a:p>
-        </p:txBody>
-      </p:sp>
-      <p:sp>
-        <p:nvSpPr>
-          <p:cNvPr id="22" name="Rectangle 21"/>
-          <p:cNvSpPr/>
-          <p:nvPr/>
-        </p:nvSpPr>
-        <p:spPr>
-          <a:xfrm>
-            <a:off x="8083296" y="3520439"/>
-            <a:ext cx="3566160" cy="1691640"/>
-          </a:xfrm>
-          <a:prstGeom prst="rect">
-            <a:avLst/>
-          </a:prstGeom>
-          <a:solidFill>
-            <a:srgbClr val="FFFFFF"/>
-          </a:solidFill>
-          <a:ln w="12700">
-            <a:solidFill>
-              <a:srgbClr val="E2E8F0"/>
-            </a:solidFill>
-          </a:ln>
-          <a:effectLst/>
-        </p:spPr>
-        <p:style>
-          <a:lnRef idx="1">
-            <a:schemeClr val="accent1"/>
-          </a:lnRef>
-          <a:fillRef idx="3">
-            <a:schemeClr val="accent1"/>
-          </a:fillRef>
-          <a:effectRef idx="2">
-            <a:schemeClr val="accent1"/>
-          </a:effectRef>
-          <a:fontRef idx="minor">
-            <a:schemeClr val="lt1"/>
-          </a:fontRef>
-        </p:style>
-        <p:txBody>
-          <a:bodyPr rtlCol="0" anchor="ctr"/>
-          <a:lstStyle/>
-          <a:p>
-            <a:pPr algn="ctr"/>
-          </a:p>
-        </p:txBody>
-      </p:sp>
-      <p:sp>
-        <p:nvSpPr>
-          <p:cNvPr id="23" name="TextBox 22"/>
-          <p:cNvSpPr txBox="1"/>
-          <p:nvPr/>
-        </p:nvSpPr>
-        <p:spPr>
-          <a:xfrm>
-            <a:off x="8083296" y="3794759"/>
-            <a:ext cx="3566160" cy="822960"/>
-          </a:xfrm>
-          <a:prstGeom prst="rect">
-            <a:avLst/>
-          </a:prstGeom>
-          <a:noFill/>
-        </p:spPr>
-        <p:txBody>
-          <a:bodyPr wrap="square" anchor="t">
-            <a:spAutoFit/>
-          </a:bodyPr>
-          <a:lstStyle/>
-          <a:p>
-            <a:pPr algn="ctr">
-              <a:lnSpc>
-                <a:spcPct val="105000"/>
-              </a:lnSpc>
-              <a:spcAft>
-                <a:spcPts val="600"/>
-              </a:spcAft>
-            </a:pPr>
-            <a:r>
-              <a:rPr sz="4000" b="1">
-                <a:solidFill>
-                  <a:srgbClr val="2563EB"/>
-                </a:solidFill>
-                <a:latin typeface="맑은 고딕"/>
-              </a:rPr>
-              <a:t>1명</a:t>
-            </a:r>
-          </a:p>
-        </p:txBody>
-      </p:sp>
-      <p:sp>
-        <p:nvSpPr>
-          <p:cNvPr id="24" name="TextBox 23"/>
-          <p:cNvSpPr txBox="1"/>
-          <p:nvPr/>
-        </p:nvSpPr>
-        <p:spPr>
-          <a:xfrm>
-            <a:off x="8083296" y="4617719"/>
-            <a:ext cx="3566160" cy="457200"/>
-          </a:xfrm>
-          <a:prstGeom prst="rect">
-            <a:avLst/>
-          </a:prstGeom>
-          <a:noFill/>
-        </p:spPr>
-        <p:txBody>
-          <a:bodyPr wrap="square" anchor="t">
-            <a:spAutoFit/>
-          </a:bodyPr>
-          <a:lstStyle/>
-          <a:p>
-            <a:pPr algn="ctr">
-              <a:lnSpc>
-                <a:spcPct val="105000"/>
-              </a:lnSpc>
-              <a:spcAft>
-                <a:spcPts val="600"/>
-              </a:spcAft>
-            </a:pPr>
-            <a:r>
-              <a:rPr sz="1400" b="0">
-                <a:solidFill>
-                  <a:srgbClr val="374151"/>
-                </a:solidFill>
-                <a:latin typeface="맑은 고딕"/>
-              </a:rPr>
-              <a:t>투입 인원</a:t>
-            </a:r>
-          </a:p>
-        </p:txBody>
-      </p:sp>
-      <p:sp>
-        <p:nvSpPr>
-          <p:cNvPr id="25" name="TextBox 24"/>
-          <p:cNvSpPr txBox="1"/>
-          <p:nvPr/>
-        </p:nvSpPr>
-        <p:spPr>
-          <a:xfrm>
-            <a:off x="548640" y="5943600"/>
-            <a:ext cx="10972800" cy="548640"/>
-          </a:xfrm>
-          <a:prstGeom prst="rect">
-            <a:avLst/>
-          </a:prstGeom>
-          <a:noFill/>
-        </p:spPr>
-        <p:txBody>
-          <a:bodyPr wrap="square" anchor="t">
-            <a:spAutoFit/>
-          </a:bodyPr>
-          <a:lstStyle/>
-          <a:p>
-            <a:pPr algn="ctr">
-              <a:lnSpc>
-                <a:spcPct val="105000"/>
-              </a:lnSpc>
-              <a:spcAft>
-                <a:spcPts val="600"/>
-              </a:spcAft>
-            </a:pPr>
-            <a:r>
-              <a:rPr sz="1500" b="0">
-                <a:solidFill>
-                  <a:srgbClr val="374151"/>
-                </a:solidFill>
-                <a:latin typeface="맑은 고딕"/>
-              </a:rPr>
-              <a:t>통상 수 명이 수개월 걸릴 풀스택 서비스를 </a:t>
-            </a:r>
-            <a:r>
-              <a:rPr sz="1500" b="1">
-                <a:solidFill>
-                  <a:srgbClr val="10B981"/>
-                </a:solidFill>
-                <a:latin typeface="맑은 고딕"/>
-              </a:rPr>
-              <a:t>1인이 3주 만에</a:t>
-            </a:r>
-            <a:r>
-              <a:rPr sz="1500" b="0">
-                <a:solidFill>
-                  <a:srgbClr val="374151"/>
-                </a:solidFill>
-                <a:latin typeface="맑은 고딕"/>
-              </a:rPr>
-              <a:t> — 이것이 생성형 AI 협업의 체감 효과입니다.</a:t>
-            </a:r>
-          </a:p>
-        </p:txBody>
-      </p:sp>
-      <p:sp>
-        <p:nvSpPr>
-          <p:cNvPr id="26" name="TextBox 25"/>
+                  <a:srgbClr val="6B7280"/>
+                </a:solidFill>
+                <a:latin typeface="맑은 고딕"/>
+              </a:rPr>
+              <a:t>   —  무단 사용을 막는 접근 장치, 비용 통제는 사람이 의도적으로 넣음</a:t>
+            </a:r>
+          </a:p>
+        </p:txBody>
+      </p:sp>
+      <p:sp>
+        <p:nvSpPr>
+          <p:cNvPr id="19" name="TextBox 18"/>
           <p:cNvSpPr txBox="1"/>
           <p:nvPr/>
         </p:nvSpPr>

</xml_diff>